<commit_message>
presentation: insert four draw.io-style diagrams as slides 11, 15, 18, 19 (pipeline overview, tech stack, app workflow, recommendation engine)
</commit_message>
<xml_diff>
--- a/presentation/RefurbIQ_PBL3.pptx
+++ b/presentation/RefurbIQ_PBL3.pptx
@@ -18,11 +18,15 @@
     <p:sldId id="795" r:id="rId16"/>
     <p:sldId id="796" r:id="rId17"/>
     <p:sldId id="797" r:id="rId18"/>
+    <p:sldId id="805" r:id="rId26"/>
     <p:sldId id="798" r:id="rId19"/>
     <p:sldId id="799" r:id="rId20"/>
     <p:sldId id="800" r:id="rId21"/>
+    <p:sldId id="806" r:id="rId27"/>
     <p:sldId id="801" r:id="rId22"/>
     <p:sldId id="802" r:id="rId23"/>
+    <p:sldId id="807" r:id="rId28"/>
+    <p:sldId id="808" r:id="rId29"/>
     <p:sldId id="803" r:id="rId24"/>
     <p:sldId id="804" r:id="rId25"/>
   </p:sldIdLst>
@@ -7608,6 +7612,146 @@
 </p:notes>
 </file>
 
+<file path=ppt/notesSlides/notesSlide18.xml><?xml version="1.0" encoding="utf-8"?>
+<p:notes xmlns:a="http://schemas.openxmlformats.org/drawingml/2006/main" xmlns:p="http://schemas.openxmlformats.org/presentationml/2006/main" xmlns:r="http://schemas.openxmlformats.org/officeDocument/2006/relationships">
+  <p:cSld>
+    <p:spTree>
+      <p:nvGrpSpPr>
+        <p:cNvPr id="1" name=""/>
+        <p:cNvGrpSpPr/>
+        <p:nvPr/>
+      </p:nvGrpSpPr>
+      <p:grpSpPr>
+        <a:xfrm>
+          <a:off x="0" y="0"/>
+          <a:ext cx="0" cy="0"/>
+          <a:chOff x="0" y="0"/>
+          <a:chExt cx="0" cy="0"/>
+        </a:xfrm>
+      </p:grpSpPr>
+      <p:sp>
+        <p:nvSpPr>
+          <p:cNvPr id="2" name="Slide Image Placeholder 1"/>
+          <p:cNvSpPr>
+            <a:spLocks noGrp="1"/>
+          </p:cNvSpPr>
+          <p:nvPr>
+            <p:ph type="sldImg" idx="2"/>
+          </p:nvPr>
+        </p:nvSpPr>
+        <p:spPr/>
+      </p:sp>
+      <p:sp>
+        <p:nvSpPr>
+          <p:cNvPr id="3" name="Notes Placeholder 2"/>
+          <p:cNvSpPr>
+            <a:spLocks noGrp="1"/>
+          </p:cNvSpPr>
+          <p:nvPr>
+            <p:ph type="body" idx="3" sz="quarter"/>
+          </p:nvPr>
+        </p:nvSpPr>
+        <p:spPr/>
+        <p:txBody>
+          <a:bodyPr/>
+          <a:lstStyle/>
+          <a:p>
+            <a:r>
+              <a:t>This is the research pipeline end to end. Step 1 was an honest verification pass: none of the five platforms exposes a structured public review corpus, so the modelling corpus is a clearly labelled synthetic demonstration dataset. The pipeline is separately validated on 2,000 real Amazon reviews, agreeing with human star ratings in 75.6% of annotations.</a:t>
+            </a:r>
+          </a:p>
+        </p:txBody>
+      </p:sp>
+      <p:sp>
+        <p:nvSpPr>
+          <p:cNvPr id="4" name="Slide Number Placeholder 3"/>
+          <p:cNvSpPr>
+            <a:spLocks noGrp="1"/>
+          </p:cNvSpPr>
+          <p:nvPr>
+            <p:ph type="sldNum" idx="5" sz="quarter"/>
+          </p:nvPr>
+        </p:nvSpPr>
+        <p:spPr/>
+      </p:sp>
+    </p:spTree>
+  </p:cSld>
+  <p:clrMapOvr>
+    <a:masterClrMapping/>
+  </p:clrMapOvr>
+</p:notes>
+</file>
+
+<file path=ppt/notesSlides/notesSlide19.xml><?xml version="1.0" encoding="utf-8"?>
+<p:notes xmlns:a="http://schemas.openxmlformats.org/drawingml/2006/main" xmlns:p="http://schemas.openxmlformats.org/presentationml/2006/main" xmlns:r="http://schemas.openxmlformats.org/officeDocument/2006/relationships">
+  <p:cSld>
+    <p:spTree>
+      <p:nvGrpSpPr>
+        <p:cNvPr id="1" name=""/>
+        <p:cNvGrpSpPr/>
+        <p:nvPr/>
+      </p:nvGrpSpPr>
+      <p:grpSpPr>
+        <a:xfrm>
+          <a:off x="0" y="0"/>
+          <a:ext cx="0" cy="0"/>
+          <a:chOff x="0" y="0"/>
+          <a:chExt cx="0" cy="0"/>
+        </a:xfrm>
+      </p:grpSpPr>
+      <p:sp>
+        <p:nvSpPr>
+          <p:cNvPr id="2" name="Slide Image Placeholder 1"/>
+          <p:cNvSpPr>
+            <a:spLocks noGrp="1"/>
+          </p:cNvSpPr>
+          <p:nvPr>
+            <p:ph type="sldImg" idx="2"/>
+          </p:nvPr>
+        </p:nvSpPr>
+        <p:spPr/>
+      </p:sp>
+      <p:sp>
+        <p:nvSpPr>
+          <p:cNvPr id="3" name="Notes Placeholder 2"/>
+          <p:cNvSpPr>
+            <a:spLocks noGrp="1"/>
+          </p:cNvSpPr>
+          <p:nvPr>
+            <p:ph type="body" idx="3" sz="quarter"/>
+          </p:nvPr>
+        </p:nvSpPr>
+        <p:spPr/>
+        <p:txBody>
+          <a:bodyPr/>
+          <a:lstStyle/>
+          <a:p>
+            <a:r>
+              <a:t>Everything is open source. Streamlit serves the eight-tab interface; Hugging Face transformers provide zero-shot RoBERTa and fine-tuned DistilBERT sentiment; scikit-learn and XGBoost give the TF-IDF baselines; pandas and matplotlib handle data and visualisation. Model weights stay local in models/ and are git-ignored.</a:t>
+            </a:r>
+          </a:p>
+        </p:txBody>
+      </p:sp>
+      <p:sp>
+        <p:nvSpPr>
+          <p:cNvPr id="4" name="Slide Number Placeholder 3"/>
+          <p:cNvSpPr>
+            <a:spLocks noGrp="1"/>
+          </p:cNvSpPr>
+          <p:nvPr>
+            <p:ph type="sldNum" idx="5" sz="quarter"/>
+          </p:nvPr>
+        </p:nvSpPr>
+        <p:spPr/>
+      </p:sp>
+    </p:spTree>
+  </p:cSld>
+  <p:clrMapOvr>
+    <a:masterClrMapping/>
+  </p:clrMapOvr>
+</p:notes>
+</file>
+
 <file path=ppt/notesSlides/notesSlide2.xml><?xml version="1.0" encoding="utf-8"?>
 <p:notes xmlns:a="http://schemas.openxmlformats.org/drawingml/2006/main" xmlns:r="http://schemas.openxmlformats.org/officeDocument/2006/relationships" xmlns:p="http://schemas.openxmlformats.org/presentationml/2006/main">
   <p:cSld>
@@ -7749,6 +7893,146 @@
         <p14:creationId xmlns:p14="http://schemas.microsoft.com/office/powerpoint/2010/main" val="951086939"/>
       </p:ext>
     </p:extLst>
+  </p:cSld>
+  <p:clrMapOvr>
+    <a:masterClrMapping/>
+  </p:clrMapOvr>
+</p:notes>
+</file>
+
+<file path=ppt/notesSlides/notesSlide20.xml><?xml version="1.0" encoding="utf-8"?>
+<p:notes xmlns:a="http://schemas.openxmlformats.org/drawingml/2006/main" xmlns:p="http://schemas.openxmlformats.org/presentationml/2006/main" xmlns:r="http://schemas.openxmlformats.org/officeDocument/2006/relationships">
+  <p:cSld>
+    <p:spTree>
+      <p:nvGrpSpPr>
+        <p:cNvPr id="1" name=""/>
+        <p:cNvGrpSpPr/>
+        <p:nvPr/>
+      </p:nvGrpSpPr>
+      <p:grpSpPr>
+        <a:xfrm>
+          <a:off x="0" y="0"/>
+          <a:ext cx="0" cy="0"/>
+          <a:chOff x="0" y="0"/>
+          <a:chExt cx="0" cy="0"/>
+        </a:xfrm>
+      </p:grpSpPr>
+      <p:sp>
+        <p:nvSpPr>
+          <p:cNvPr id="2" name="Slide Image Placeholder 1"/>
+          <p:cNvSpPr>
+            <a:spLocks noGrp="1"/>
+          </p:cNvSpPr>
+          <p:nvPr>
+            <p:ph type="sldImg" idx="2"/>
+          </p:nvPr>
+        </p:nvSpPr>
+        <p:spPr/>
+      </p:sp>
+      <p:sp>
+        <p:nvSpPr>
+          <p:cNvPr id="3" name="Notes Placeholder 2"/>
+          <p:cNvSpPr>
+            <a:spLocks noGrp="1"/>
+          </p:cNvSpPr>
+          <p:nvPr>
+            <p:ph type="body" idx="3" sz="quarter"/>
+          </p:nvPr>
+        </p:nvSpPr>
+        <p:spPr/>
+        <p:txBody>
+          <a:bodyPr/>
+          <a:lstStyle/>
+          <a:p>
+            <a:r>
+              <a:t>The app takes an uploaded review CSV (or the bundled demo corpus), cleans it, extracts aspects through the 13-aspect keyword vocabulary, runs whole-review sentiment, and produces the ABSA results table. That feeds two branches: the analytics dashboard and the recommendation engine, which powers Compare Platforms, Best Place to Buy and Explain Recommendation.</a:t>
+            </a:r>
+          </a:p>
+        </p:txBody>
+      </p:sp>
+      <p:sp>
+        <p:nvSpPr>
+          <p:cNvPr id="4" name="Slide Number Placeholder 3"/>
+          <p:cNvSpPr>
+            <a:spLocks noGrp="1"/>
+          </p:cNvSpPr>
+          <p:nvPr>
+            <p:ph type="sldNum" idx="5" sz="quarter"/>
+          </p:nvPr>
+        </p:nvSpPr>
+        <p:spPr/>
+      </p:sp>
+    </p:spTree>
+  </p:cSld>
+  <p:clrMapOvr>
+    <a:masterClrMapping/>
+  </p:clrMapOvr>
+</p:notes>
+</file>
+
+<file path=ppt/notesSlides/notesSlide21.xml><?xml version="1.0" encoding="utf-8"?>
+<p:notes xmlns:a="http://schemas.openxmlformats.org/drawingml/2006/main" xmlns:p="http://schemas.openxmlformats.org/presentationml/2006/main" xmlns:r="http://schemas.openxmlformats.org/officeDocument/2006/relationships">
+  <p:cSld>
+    <p:spTree>
+      <p:nvGrpSpPr>
+        <p:cNvPr id="1" name=""/>
+        <p:cNvGrpSpPr/>
+        <p:nvPr/>
+      </p:nvGrpSpPr>
+      <p:grpSpPr>
+        <a:xfrm>
+          <a:off x="0" y="0"/>
+          <a:ext cx="0" cy="0"/>
+          <a:chOff x="0" y="0"/>
+          <a:chExt cx="0" cy="0"/>
+        </a:xfrm>
+      </p:grpSpPr>
+      <p:sp>
+        <p:nvSpPr>
+          <p:cNvPr id="2" name="Slide Image Placeholder 1"/>
+          <p:cNvSpPr>
+            <a:spLocks noGrp="1"/>
+          </p:cNvSpPr>
+          <p:nvPr>
+            <p:ph type="sldImg" idx="2"/>
+          </p:nvPr>
+        </p:nvSpPr>
+        <p:spPr/>
+      </p:sp>
+      <p:sp>
+        <p:nvSpPr>
+          <p:cNvPr id="3" name="Notes Placeholder 2"/>
+          <p:cNvSpPr>
+            <a:spLocks noGrp="1"/>
+          </p:cNvSpPr>
+          <p:nvPr>
+            <p:ph type="body" idx="3" sz="quarter"/>
+          </p:nvPr>
+        </p:nvSpPr>
+        <p:spPr/>
+        <p:txBody>
+          <a:bodyPr/>
+          <a:lstStyle/>
+          <a:p>
+            <a:r>
+              <a:t>The overall score is a weighted sum of six transparent sub-scores: sentiment 0.25, product quality 0.25, service 0.15, value 0.15, trust 0.10 and return/refund 0.10. A confidence gate requires at least 20 reviews before any recommendation is made, and HIGH confidence additionally needs 50+ reviews with consistent sentiment.</a:t>
+            </a:r>
+          </a:p>
+        </p:txBody>
+      </p:sp>
+      <p:sp>
+        <p:nvSpPr>
+          <p:cNvPr id="4" name="Slide Number Placeholder 3"/>
+          <p:cNvSpPr>
+            <a:spLocks noGrp="1"/>
+          </p:cNvSpPr>
+          <p:nvPr>
+            <p:ph type="sldNum" idx="5" sz="quarter"/>
+          </p:nvPr>
+        </p:nvSpPr>
+        <p:spPr/>
+      </p:sp>
+    </p:spTree>
   </p:cSld>
   <p:clrMapOvr>
     <a:masterClrMapping/>
@@ -17617,6 +17901,146 @@
 </p:sld>
 </file>
 
+<file path=ppt/slides/slide18.xml><?xml version="1.0" encoding="utf-8"?>
+<p:sld xmlns:a="http://schemas.openxmlformats.org/drawingml/2006/main" xmlns:p="http://schemas.openxmlformats.org/presentationml/2006/main" xmlns:r="http://schemas.openxmlformats.org/officeDocument/2006/relationships">
+  <p:cSld>
+    <p:spTree>
+      <p:nvGrpSpPr>
+        <p:cNvPr id="1" name=""/>
+        <p:cNvGrpSpPr/>
+        <p:nvPr/>
+      </p:nvGrpSpPr>
+      <p:grpSpPr/>
+      <p:sp>
+        <p:nvSpPr>
+          <p:cNvPr id="2" name="Title 1"/>
+          <p:cNvSpPr>
+            <a:spLocks noGrp="1"/>
+          </p:cNvSpPr>
+          <p:nvPr>
+            <p:ph type="title"/>
+          </p:nvPr>
+        </p:nvSpPr>
+        <p:spPr/>
+        <p:txBody>
+          <a:bodyPr/>
+          <a:lstStyle/>
+          <a:p>
+            <a:pPr algn="ctr"/>
+            <a:r>
+              <a:rPr sz="3000" b="1">
+                <a:solidFill>
+                  <a:srgbClr val="1F3864"/>
+                </a:solidFill>
+                <a:latin typeface="Times New Roman"/>
+              </a:rPr>
+              <a:t>Methodology: Pipeline Overview</a:t>
+            </a:r>
+          </a:p>
+        </p:txBody>
+      </p:sp>
+      <p:pic>
+        <p:nvPicPr>
+          <p:cNvPr id="3" name="Picture 2" descr="3_diagram_research_pipeline.png"/>
+          <p:cNvPicPr>
+            <a:picLocks noChangeAspect="1"/>
+          </p:cNvPicPr>
+          <p:nvPr/>
+        </p:nvPicPr>
+        <p:blipFill>
+          <a:blip r:embed="rId2"/>
+          <a:stretch>
+            <a:fillRect/>
+          </a:stretch>
+        </p:blipFill>
+        <p:spPr>
+          <a:xfrm>
+            <a:off x="987292" y="1133856"/>
+            <a:ext cx="7169414" cy="5138927"/>
+          </a:xfrm>
+          <a:prstGeom prst="rect">
+            <a:avLst/>
+          </a:prstGeom>
+        </p:spPr>
+      </p:pic>
+    </p:spTree>
+  </p:cSld>
+  <p:clrMapOvr>
+    <a:masterClrMapping/>
+  </p:clrMapOvr>
+</p:sld>
+</file>
+
+<file path=ppt/slides/slide19.xml><?xml version="1.0" encoding="utf-8"?>
+<p:sld xmlns:a="http://schemas.openxmlformats.org/drawingml/2006/main" xmlns:p="http://schemas.openxmlformats.org/presentationml/2006/main" xmlns:r="http://schemas.openxmlformats.org/officeDocument/2006/relationships">
+  <p:cSld>
+    <p:spTree>
+      <p:nvGrpSpPr>
+        <p:cNvPr id="1" name=""/>
+        <p:cNvGrpSpPr/>
+        <p:nvPr/>
+      </p:nvGrpSpPr>
+      <p:grpSpPr/>
+      <p:sp>
+        <p:nvSpPr>
+          <p:cNvPr id="2" name="Title 1"/>
+          <p:cNvSpPr>
+            <a:spLocks noGrp="1"/>
+          </p:cNvSpPr>
+          <p:nvPr>
+            <p:ph type="title"/>
+          </p:nvPr>
+        </p:nvSpPr>
+        <p:spPr/>
+        <p:txBody>
+          <a:bodyPr/>
+          <a:lstStyle/>
+          <a:p>
+            <a:pPr algn="ctr"/>
+            <a:r>
+              <a:rPr sz="3000" b="1">
+                <a:solidFill>
+                  <a:srgbClr val="1F3864"/>
+                </a:solidFill>
+                <a:latin typeface="Times New Roman"/>
+              </a:rPr>
+              <a:t>Technology Stack</a:t>
+            </a:r>
+          </a:p>
+        </p:txBody>
+      </p:sp>
+      <p:pic>
+        <p:nvPicPr>
+          <p:cNvPr id="3" name="Picture 2" descr="1_diagram_tech_stack.png"/>
+          <p:cNvPicPr>
+            <a:picLocks noChangeAspect="1"/>
+          </p:cNvPicPr>
+          <p:nvPr/>
+        </p:nvPicPr>
+        <p:blipFill>
+          <a:blip r:embed="rId2"/>
+          <a:stretch>
+            <a:fillRect/>
+          </a:stretch>
+        </p:blipFill>
+        <p:spPr>
+          <a:xfrm>
+            <a:off x="755696" y="1133856"/>
+            <a:ext cx="7632607" cy="5138928"/>
+          </a:xfrm>
+          <a:prstGeom prst="rect">
+            <a:avLst/>
+          </a:prstGeom>
+        </p:spPr>
+      </p:pic>
+    </p:spTree>
+  </p:cSld>
+  <p:clrMapOvr>
+    <a:masterClrMapping/>
+  </p:clrMapOvr>
+</p:sld>
+</file>
+
 <file path=ppt/slides/slide2.xml><?xml version="1.0" encoding="utf-8"?>
 <p:sld xmlns:a="http://schemas.openxmlformats.org/drawingml/2006/main" xmlns:r="http://schemas.openxmlformats.org/officeDocument/2006/relationships" xmlns:p="http://schemas.openxmlformats.org/presentationml/2006/main">
   <p:cSld>
@@ -17692,6 +18116,146 @@
           </a:graphicData>
         </a:graphic>
       </p:graphicFrame>
+    </p:spTree>
+  </p:cSld>
+  <p:clrMapOvr>
+    <a:masterClrMapping/>
+  </p:clrMapOvr>
+</p:sld>
+</file>
+
+<file path=ppt/slides/slide20.xml><?xml version="1.0" encoding="utf-8"?>
+<p:sld xmlns:a="http://schemas.openxmlformats.org/drawingml/2006/main" xmlns:p="http://schemas.openxmlformats.org/presentationml/2006/main" xmlns:r="http://schemas.openxmlformats.org/officeDocument/2006/relationships">
+  <p:cSld>
+    <p:spTree>
+      <p:nvGrpSpPr>
+        <p:cNvPr id="1" name=""/>
+        <p:cNvGrpSpPr/>
+        <p:nvPr/>
+      </p:nvGrpSpPr>
+      <p:grpSpPr/>
+      <p:sp>
+        <p:nvSpPr>
+          <p:cNvPr id="2" name="Title 1"/>
+          <p:cNvSpPr>
+            <a:spLocks noGrp="1"/>
+          </p:cNvSpPr>
+          <p:nvPr>
+            <p:ph type="title"/>
+          </p:nvPr>
+        </p:nvSpPr>
+        <p:spPr/>
+        <p:txBody>
+          <a:bodyPr/>
+          <a:lstStyle/>
+          <a:p>
+            <a:pPr algn="ctr"/>
+            <a:r>
+              <a:rPr sz="3000" b="1">
+                <a:solidFill>
+                  <a:srgbClr val="1F3864"/>
+                </a:solidFill>
+                <a:latin typeface="Times New Roman"/>
+              </a:rPr>
+              <a:t>System Design: App Workflow</a:t>
+            </a:r>
+          </a:p>
+        </p:txBody>
+      </p:sp>
+      <p:pic>
+        <p:nvPicPr>
+          <p:cNvPr id="3" name="Picture 2" descr="2_diagram_app_workflow.png"/>
+          <p:cNvPicPr>
+            <a:picLocks noChangeAspect="1"/>
+          </p:cNvPicPr>
+          <p:nvPr/>
+        </p:nvPicPr>
+        <p:blipFill>
+          <a:blip r:embed="rId2"/>
+          <a:stretch>
+            <a:fillRect/>
+          </a:stretch>
+        </p:blipFill>
+        <p:spPr>
+          <a:xfrm>
+            <a:off x="670767" y="1133856"/>
+            <a:ext cx="7802464" cy="5138928"/>
+          </a:xfrm>
+          <a:prstGeom prst="rect">
+            <a:avLst/>
+          </a:prstGeom>
+        </p:spPr>
+      </p:pic>
+    </p:spTree>
+  </p:cSld>
+  <p:clrMapOvr>
+    <a:masterClrMapping/>
+  </p:clrMapOvr>
+</p:sld>
+</file>
+
+<file path=ppt/slides/slide21.xml><?xml version="1.0" encoding="utf-8"?>
+<p:sld xmlns:a="http://schemas.openxmlformats.org/drawingml/2006/main" xmlns:p="http://schemas.openxmlformats.org/presentationml/2006/main" xmlns:r="http://schemas.openxmlformats.org/officeDocument/2006/relationships">
+  <p:cSld>
+    <p:spTree>
+      <p:nvGrpSpPr>
+        <p:cNvPr id="1" name=""/>
+        <p:cNvGrpSpPr/>
+        <p:nvPr/>
+      </p:nvGrpSpPr>
+      <p:grpSpPr/>
+      <p:sp>
+        <p:nvSpPr>
+          <p:cNvPr id="2" name="Title 1"/>
+          <p:cNvSpPr>
+            <a:spLocks noGrp="1"/>
+          </p:cNvSpPr>
+          <p:nvPr>
+            <p:ph type="title"/>
+          </p:nvPr>
+        </p:nvSpPr>
+        <p:spPr/>
+        <p:txBody>
+          <a:bodyPr/>
+          <a:lstStyle/>
+          <a:p>
+            <a:pPr algn="ctr"/>
+            <a:r>
+              <a:rPr sz="3000" b="1">
+                <a:solidFill>
+                  <a:srgbClr val="1F3864"/>
+                </a:solidFill>
+                <a:latin typeface="Times New Roman"/>
+              </a:rPr>
+              <a:t>Recommendation Engine</a:t>
+            </a:r>
+          </a:p>
+        </p:txBody>
+      </p:sp>
+      <p:pic>
+        <p:nvPicPr>
+          <p:cNvPr id="3" name="Picture 2" descr="4_diagram_recommendation.png"/>
+          <p:cNvPicPr>
+            <a:picLocks noChangeAspect="1"/>
+          </p:cNvPicPr>
+          <p:nvPr/>
+        </p:nvPicPr>
+        <p:blipFill>
+          <a:blip r:embed="rId2"/>
+          <a:stretch>
+            <a:fillRect/>
+          </a:stretch>
+        </p:blipFill>
+        <p:spPr>
+          <a:xfrm>
+            <a:off x="492107" y="1133856"/>
+            <a:ext cx="8159784" cy="5138928"/>
+          </a:xfrm>
+          <a:prstGeom prst="rect">
+            <a:avLst/>
+          </a:prstGeom>
+        </p:spPr>
+      </p:pic>
     </p:spTree>
   </p:cSld>
   <p:clrMapOvr>

</xml_diff>

<commit_message>
presentation: fill student name, registration number and mentor name on title slide
</commit_message>
<xml_diff>
--- a/presentation/RefurbIQ_PBL3.pptx
+++ b/presentation/RefurbIQ_PBL3.pptx
@@ -11802,7 +11802,7 @@
                           </a:solidFill>
                           <a:latin typeface="Times New Roman"/>
                         </a:rPr>
-                        <a:t>Saket Sharma ([REG NO])</a:t>
+                        <a:t>Saket Sharma (2430010408)</a:t>
                       </a:r>
                     </a:p>
                   </a:txBody>
@@ -11856,7 +11856,7 @@
                           </a:solidFill>
                           <a:latin typeface="Times New Roman"/>
                         </a:rPr>
-                        <a:t>[Guide name(s)]</a:t>
+                        <a:t>Dr Ashish Pandey</a:t>
                       </a:r>
                     </a:p>
                   </a:txBody>
@@ -12791,6 +12791,76 @@
 <file path=ppt/slides/slide11.xml><?xml version="1.0" encoding="utf-8"?>
 <p:sld xmlns:a="http://schemas.openxmlformats.org/drawingml/2006/main" xmlns:p="http://schemas.openxmlformats.org/presentationml/2006/main" xmlns:r="http://schemas.openxmlformats.org/officeDocument/2006/relationships">
   <p:cSld>
+    <p:spTree>
+      <p:nvGrpSpPr>
+        <p:cNvPr id="1" name=""/>
+        <p:cNvGrpSpPr/>
+        <p:nvPr/>
+      </p:nvGrpSpPr>
+      <p:grpSpPr/>
+      <p:sp>
+        <p:nvSpPr>
+          <p:cNvPr id="2" name="Title 1"/>
+          <p:cNvSpPr>
+            <a:spLocks noGrp="1"/>
+          </p:cNvSpPr>
+          <p:nvPr>
+            <p:ph type="title"/>
+          </p:nvPr>
+        </p:nvSpPr>
+        <p:spPr/>
+        <p:txBody>
+          <a:bodyPr/>
+          <a:lstStyle/>
+          <a:p>
+            <a:pPr algn="ctr"/>
+            <a:r>
+              <a:rPr sz="3000" b="1">
+                <a:solidFill>
+                  <a:srgbClr val="1F3864"/>
+                </a:solidFill>
+                <a:latin typeface="Times New Roman"/>
+              </a:rPr>
+              <a:t>Methodology: Pipeline Overview</a:t>
+            </a:r>
+          </a:p>
+        </p:txBody>
+      </p:sp>
+      <p:pic>
+        <p:nvPicPr>
+          <p:cNvPr id="3" name="Picture 2" descr="3_diagram_research_pipeline.png"/>
+          <p:cNvPicPr>
+            <a:picLocks noChangeAspect="1"/>
+          </p:cNvPicPr>
+          <p:nvPr/>
+        </p:nvPicPr>
+        <p:blipFill>
+          <a:blip r:embed="rId2"/>
+          <a:stretch>
+            <a:fillRect/>
+          </a:stretch>
+        </p:blipFill>
+        <p:spPr>
+          <a:xfrm>
+            <a:off x="987292" y="1133856"/>
+            <a:ext cx="7169414" cy="5138927"/>
+          </a:xfrm>
+          <a:prstGeom prst="rect">
+            <a:avLst/>
+          </a:prstGeom>
+        </p:spPr>
+      </p:pic>
+    </p:spTree>
+  </p:cSld>
+  <p:clrMapOvr>
+    <a:masterClrMapping/>
+  </p:clrMapOvr>
+</p:sld>
+</file>
+
+<file path=ppt/slides/slide12.xml><?xml version="1.0" encoding="utf-8"?>
+<p:sld xmlns:a="http://schemas.openxmlformats.org/drawingml/2006/main" xmlns:p="http://schemas.openxmlformats.org/presentationml/2006/main" xmlns:r="http://schemas.openxmlformats.org/officeDocument/2006/relationships">
+  <p:cSld>
     <p:bg>
       <p:bgPr>
         <a:blipFill>
@@ -13470,7 +13540,7 @@
 </p:sld>
 </file>
 
-<file path=ppt/slides/slide12.xml><?xml version="1.0" encoding="utf-8"?>
+<file path=ppt/slides/slide13.xml><?xml version="1.0" encoding="utf-8"?>
 <p:sld xmlns:a="http://schemas.openxmlformats.org/drawingml/2006/main" xmlns:p="http://schemas.openxmlformats.org/presentationml/2006/main" xmlns:r="http://schemas.openxmlformats.org/officeDocument/2006/relationships">
   <p:cSld>
     <p:bg>
@@ -14224,7 +14294,7 @@
 </p:sld>
 </file>
 
-<file path=ppt/slides/slide13.xml><?xml version="1.0" encoding="utf-8"?>
+<file path=ppt/slides/slide14.xml><?xml version="1.0" encoding="utf-8"?>
 <p:sld xmlns:a="http://schemas.openxmlformats.org/drawingml/2006/main" xmlns:p="http://schemas.openxmlformats.org/presentationml/2006/main" xmlns:r="http://schemas.openxmlformats.org/officeDocument/2006/relationships">
   <p:cSld>
     <p:bg>
@@ -15159,7 +15229,77 @@
 </p:sld>
 </file>
 
-<file path=ppt/slides/slide14.xml><?xml version="1.0" encoding="utf-8"?>
+<file path=ppt/slides/slide15.xml><?xml version="1.0" encoding="utf-8"?>
+<p:sld xmlns:a="http://schemas.openxmlformats.org/drawingml/2006/main" xmlns:p="http://schemas.openxmlformats.org/presentationml/2006/main" xmlns:r="http://schemas.openxmlformats.org/officeDocument/2006/relationships">
+  <p:cSld>
+    <p:spTree>
+      <p:nvGrpSpPr>
+        <p:cNvPr id="1" name=""/>
+        <p:cNvGrpSpPr/>
+        <p:nvPr/>
+      </p:nvGrpSpPr>
+      <p:grpSpPr/>
+      <p:sp>
+        <p:nvSpPr>
+          <p:cNvPr id="2" name="Title 1"/>
+          <p:cNvSpPr>
+            <a:spLocks noGrp="1"/>
+          </p:cNvSpPr>
+          <p:nvPr>
+            <p:ph type="title"/>
+          </p:nvPr>
+        </p:nvSpPr>
+        <p:spPr/>
+        <p:txBody>
+          <a:bodyPr/>
+          <a:lstStyle/>
+          <a:p>
+            <a:pPr algn="ctr"/>
+            <a:r>
+              <a:rPr sz="3000" b="1">
+                <a:solidFill>
+                  <a:srgbClr val="1F3864"/>
+                </a:solidFill>
+                <a:latin typeface="Times New Roman"/>
+              </a:rPr>
+              <a:t>Technology Stack</a:t>
+            </a:r>
+          </a:p>
+        </p:txBody>
+      </p:sp>
+      <p:pic>
+        <p:nvPicPr>
+          <p:cNvPr id="3" name="Picture 2" descr="1_diagram_tech_stack.png"/>
+          <p:cNvPicPr>
+            <a:picLocks noChangeAspect="1"/>
+          </p:cNvPicPr>
+          <p:nvPr/>
+        </p:nvPicPr>
+        <p:blipFill>
+          <a:blip r:embed="rId2"/>
+          <a:stretch>
+            <a:fillRect/>
+          </a:stretch>
+        </p:blipFill>
+        <p:spPr>
+          <a:xfrm>
+            <a:off x="755696" y="1133856"/>
+            <a:ext cx="7632607" cy="5138928"/>
+          </a:xfrm>
+          <a:prstGeom prst="rect">
+            <a:avLst/>
+          </a:prstGeom>
+        </p:spPr>
+      </p:pic>
+    </p:spTree>
+  </p:cSld>
+  <p:clrMapOvr>
+    <a:masterClrMapping/>
+  </p:clrMapOvr>
+</p:sld>
+</file>
+
+<file path=ppt/slides/slide16.xml><?xml version="1.0" encoding="utf-8"?>
 <p:sld xmlns:a="http://schemas.openxmlformats.org/drawingml/2006/main" xmlns:p="http://schemas.openxmlformats.org/presentationml/2006/main" xmlns:r="http://schemas.openxmlformats.org/officeDocument/2006/relationships">
   <p:cSld>
     <p:bg>
@@ -15646,7 +15786,7 @@
 </p:sld>
 </file>
 
-<file path=ppt/slides/slide15.xml><?xml version="1.0" encoding="utf-8"?>
+<file path=ppt/slides/slide17.xml><?xml version="1.0" encoding="utf-8"?>
 <p:sld xmlns:a="http://schemas.openxmlformats.org/drawingml/2006/main" xmlns:p="http://schemas.openxmlformats.org/presentationml/2006/main" xmlns:r="http://schemas.openxmlformats.org/officeDocument/2006/relationships">
   <p:cSld>
     <p:bg>
@@ -16281,1626 +16421,6 @@
 </p:sld>
 </file>
 
-<file path=ppt/slides/slide16.xml><?xml version="1.0" encoding="utf-8"?>
-<p:sld xmlns:a="http://schemas.openxmlformats.org/drawingml/2006/main" xmlns:p="http://schemas.openxmlformats.org/presentationml/2006/main" xmlns:r="http://schemas.openxmlformats.org/officeDocument/2006/relationships">
-  <p:cSld>
-    <p:bg>
-      <p:bgPr>
-        <a:blipFill>
-          <a:blip r:embed="rId2"/>
-          <a:tile tx="0" ty="0" sx="100000" sy="100000" flip="none" algn="tl"/>
-        </a:blipFill>
-        <a:effectLst/>
-      </p:bgPr>
-    </p:bg>
-    <p:spTree>
-      <p:nvGrpSpPr>
-        <p:cNvPr id="1" name=""/>
-        <p:cNvGrpSpPr/>
-        <p:nvPr/>
-      </p:nvGrpSpPr>
-      <p:grpSpPr/>
-      <p:sp>
-        <p:nvSpPr>
-          <p:cNvPr id="2" name="Title 1"/>
-          <p:cNvSpPr>
-            <a:spLocks noGrp="1"/>
-          </p:cNvSpPr>
-          <p:nvPr>
-            <p:ph type="title"/>
-          </p:nvPr>
-        </p:nvSpPr>
-        <p:spPr>
-          <a:xfrm>
-            <a:off x="446314" y="122238"/>
-            <a:ext cx="8229600" cy="868362"/>
-          </a:xfrm>
-          <a:prstGeom prst="roundRect">
-            <a:avLst/>
-          </a:prstGeom>
-          <a:solidFill>
-            <a:srgbClr val="E6EFF4"/>
-          </a:solidFill>
-          <a:ln w="19050">
-            <a:solidFill>
-              <a:srgbClr val="FFFFFF"/>
-            </a:solidFill>
-          </a:ln>
-        </p:spPr>
-        <p:txBody>
-          <a:bodyPr anchor="ctr"/>
-          <a:lstStyle/>
-          <a:p>
-            <a:pPr algn="ctr"/>
-            <a:r>
-              <a:rPr sz="3000" b="1">
-                <a:solidFill>
-                  <a:srgbClr val="1F3864"/>
-                </a:solidFill>
-                <a:latin typeface="Times New Roman"/>
-              </a:rPr>
-              <a:t>Outcome: Research Paper and Deliverables</a:t>
-            </a:r>
-          </a:p>
-        </p:txBody>
-      </p:sp>
-      <p:sp>
-        <p:nvSpPr>
-          <p:cNvPr id="6" name="Slide Number Placeholder 5">
-            <a:extLst>
-              <a:ext uri="{FF2B5EF4-FFF2-40B4-BE49-F238E27FC236}">
-                <a16:creationId xmlns:a16="http://schemas.microsoft.com/office/drawing/2014/main" id="{B0CEE340-DD05-ABF3-E2C1-1FCA7E601094}"/>
-              </a:ext>
-            </a:extLst>
-          </p:cNvPr>
-          <p:cNvSpPr>
-            <a:spLocks noGrp="1"/>
-          </p:cNvSpPr>
-          <p:nvPr>
-            <p:ph type="sldNum" sz="quarter" idx="12"/>
-          </p:nvPr>
-        </p:nvSpPr>
-        <p:spPr/>
-        <p:txBody>
-          <a:bodyPr/>
-          <a:lstStyle/>
-          <a:p>
-            <a:fld id="{D0D3D9D9-2323-4B14-959B-DD5C508B8A7B}" type="slidenum">
-              <a:rPr lang="en-US" b="1" smtClean="0"/>
-              <a:pPr/>
-              <a:t>1</a:t>
-            </a:fld>
-            <a:endParaRPr lang="en-US" b="1" dirty="0"/>
-          </a:p>
-        </p:txBody>
-      </p:sp>
-      <p:sp>
-        <p:nvSpPr>
-          <p:cNvPr id="7" name="IP card"/>
-          <p:cNvSpPr/>
-          <p:nvPr/>
-        </p:nvSpPr>
-        <p:spPr>
-          <a:xfrm>
-            <a:off x="365760" y="1188720"/>
-            <a:ext cx="4480560" cy="4023360"/>
-          </a:xfrm>
-          <a:prstGeom prst="roundRect">
-            <a:avLst>
-              <a:gd name="adj" fmla="val 8000"/>
-            </a:avLst>
-          </a:prstGeom>
-          <a:solidFill>
-            <a:srgbClr val="FFFFFF"/>
-          </a:solidFill>
-          <a:ln w="12700">
-            <a:solidFill>
-              <a:srgbClr val="9DB7C9"/>
-            </a:solidFill>
-          </a:ln>
-          <a:effectLst/>
-        </p:spPr>
-        <p:style>
-          <a:lnRef idx="1">
-            <a:schemeClr val="accent1"/>
-          </a:lnRef>
-          <a:fillRef idx="3">
-            <a:schemeClr val="accent1"/>
-          </a:fillRef>
-          <a:effectRef idx="2">
-            <a:schemeClr val="accent1"/>
-          </a:effectRef>
-          <a:fontRef idx="minor">
-            <a:schemeClr val="lt1"/>
-          </a:fontRef>
-        </p:style>
-        <p:txBody>
-          <a:bodyPr rtlCol="0" anchor="ctr"/>
-          <a:lstStyle/>
-          <a:p>
-            <a:pPr algn="ctr"/>
-          </a:p>
-        </p:txBody>
-      </p:sp>
-      <p:sp>
-        <p:nvSpPr>
-          <p:cNvPr id="8" name="IP card head"/>
-          <p:cNvSpPr txBox="1"/>
-          <p:nvPr/>
-        </p:nvSpPr>
-        <p:spPr>
-          <a:xfrm>
-            <a:off x="594360" y="1353312"/>
-            <a:ext cx="4023360" cy="411480"/>
-          </a:xfrm>
-          <a:prstGeom prst="rect">
-            <a:avLst/>
-          </a:prstGeom>
-          <a:noFill/>
-        </p:spPr>
-        <p:txBody>
-          <a:bodyPr wrap="square" anchor="t" lIns="0" rIns="0" tIns="0" bIns="0">
-            <a:spAutoFit/>
-          </a:bodyPr>
-          <a:lstStyle/>
-          <a:p>
-            <a:pPr algn="l"/>
-            <a:r>
-              <a:rPr sz="1900" b="1">
-                <a:solidFill>
-                  <a:srgbClr val="1F3864"/>
-                </a:solidFill>
-                <a:latin typeface="Times New Roman"/>
-              </a:rPr>
-              <a:t>Research output</a:t>
-            </a:r>
-          </a:p>
-        </p:txBody>
-      </p:sp>
-      <p:sp>
-        <p:nvSpPr>
-          <p:cNvPr id="9" name="IP points"/>
-          <p:cNvSpPr txBox="1"/>
-          <p:nvPr/>
-        </p:nvSpPr>
-        <p:spPr>
-          <a:xfrm>
-            <a:off x="594360" y="1737360"/>
-            <a:ext cx="4023360" cy="3429000"/>
-          </a:xfrm>
-          <a:prstGeom prst="rect">
-            <a:avLst/>
-          </a:prstGeom>
-          <a:noFill/>
-        </p:spPr>
-        <p:txBody>
-          <a:bodyPr wrap="square" anchor="t" lIns="0" rIns="0" tIns="0" bIns="0">
-            <a:spAutoFit/>
-          </a:bodyPr>
-          <a:lstStyle/>
-          <a:p>
-            <a:pPr marL="228600" indent="-228600">
-              <a:spcAft>
-                <a:spcPts val="700"/>
-              </a:spcAft>
-              <a:buFont typeface="Arial"/>
-              <a:buChar char="•"/>
-            </a:pPr>
-            <a:r>
-              <a:rPr sz="1600" b="1">
-                <a:solidFill>
-                  <a:srgbClr val="1F3864"/>
-                </a:solidFill>
-                <a:latin typeface="Times New Roman"/>
-              </a:rPr>
-              <a:t>RefurbIQ paper draft in progress: all six results tables filled from computed outputs</a:t>
-            </a:r>
-          </a:p>
-          <a:p>
-            <a:pPr marL="228600" indent="-228600">
-              <a:spcAft>
-                <a:spcPts val="700"/>
-              </a:spcAft>
-              <a:buFont typeface="Arial"/>
-              <a:buChar char="•"/>
-            </a:pPr>
-            <a:r>
-              <a:rPr sz="1600" b="1">
-                <a:solidFill>
-                  <a:srgbClr val="1F3864"/>
-                </a:solidFill>
-                <a:latin typeface="Times New Roman"/>
-              </a:rPr>
-              <a:t>Planned venue: [XX]</a:t>
-            </a:r>
-          </a:p>
-          <a:p>
-            <a:pPr marL="228600" indent="-228600">
-              <a:spcAft>
-                <a:spcPts val="700"/>
-              </a:spcAft>
-              <a:buFont typeface="Arial"/>
-              <a:buChar char="•"/>
-            </a:pPr>
-            <a:r>
-              <a:rPr sz="1600" b="1">
-                <a:solidFill>
-                  <a:srgbClr val="1F3864"/>
-                </a:solidFill>
-                <a:latin typeface="Times New Roman"/>
-              </a:rPr>
-              <a:t>Every reported number is reproducible via the scripts in research/scripts/</a:t>
-            </a:r>
-          </a:p>
-          <a:p>
-            <a:pPr marL="228600" indent="-228600">
-              <a:spcAft>
-                <a:spcPts val="700"/>
-              </a:spcAft>
-              <a:buFont typeface="Arial"/>
-              <a:buChar char="•"/>
-            </a:pPr>
-            <a:r>
-              <a:rPr sz="1600" b="1">
-                <a:solidFill>
-                  <a:srgbClr val="1F3864"/>
-                </a:solidFill>
-                <a:latin typeface="Times New Roman"/>
-              </a:rPr>
-              <a:t>Dataset is labelled synthetic; real-review validation is the next step</a:t>
-            </a:r>
-          </a:p>
-        </p:txBody>
-      </p:sp>
-      <p:sp>
-        <p:nvSpPr>
-          <p:cNvPr id="10" name="Deliverables card"/>
-          <p:cNvSpPr/>
-          <p:nvPr/>
-        </p:nvSpPr>
-        <p:spPr>
-          <a:xfrm>
-            <a:off x="5029200" y="1188720"/>
-            <a:ext cx="3566160" cy="4023360"/>
-          </a:xfrm>
-          <a:prstGeom prst="roundRect">
-            <a:avLst>
-              <a:gd name="adj" fmla="val 8000"/>
-            </a:avLst>
-          </a:prstGeom>
-          <a:solidFill>
-            <a:srgbClr val="E4F3F1"/>
-          </a:solidFill>
-          <a:ln w="12700">
-            <a:solidFill>
-              <a:srgbClr val="9DB7C9"/>
-            </a:solidFill>
-          </a:ln>
-          <a:effectLst/>
-        </p:spPr>
-        <p:style>
-          <a:lnRef idx="1">
-            <a:schemeClr val="accent1"/>
-          </a:lnRef>
-          <a:fillRef idx="3">
-            <a:schemeClr val="accent1"/>
-          </a:fillRef>
-          <a:effectRef idx="2">
-            <a:schemeClr val="accent1"/>
-          </a:effectRef>
-          <a:fontRef idx="minor">
-            <a:schemeClr val="lt1"/>
-          </a:fontRef>
-        </p:style>
-        <p:txBody>
-          <a:bodyPr rtlCol="0" anchor="ctr"/>
-          <a:lstStyle/>
-          <a:p>
-            <a:pPr algn="ctr"/>
-          </a:p>
-        </p:txBody>
-      </p:sp>
-      <p:sp>
-        <p:nvSpPr>
-          <p:cNvPr id="11" name="Deliverables card head"/>
-          <p:cNvSpPr txBox="1"/>
-          <p:nvPr/>
-        </p:nvSpPr>
-        <p:spPr>
-          <a:xfrm>
-            <a:off x="5257800" y="1353312"/>
-            <a:ext cx="3108960" cy="411480"/>
-          </a:xfrm>
-          <a:prstGeom prst="rect">
-            <a:avLst/>
-          </a:prstGeom>
-          <a:noFill/>
-        </p:spPr>
-        <p:txBody>
-          <a:bodyPr wrap="square" anchor="t" lIns="0" rIns="0" tIns="0" bIns="0">
-            <a:spAutoFit/>
-          </a:bodyPr>
-          <a:lstStyle/>
-          <a:p>
-            <a:pPr algn="l"/>
-            <a:r>
-              <a:rPr sz="1900" b="1">
-                <a:solidFill>
-                  <a:srgbClr val="1F6F78"/>
-                </a:solidFill>
-                <a:latin typeface="Times New Roman"/>
-              </a:rPr>
-              <a:t>Deliverables</a:t>
-            </a:r>
-          </a:p>
-        </p:txBody>
-      </p:sp>
-      <p:sp>
-        <p:nvSpPr>
-          <p:cNvPr id="12" name="Deliverables points"/>
-          <p:cNvSpPr txBox="1"/>
-          <p:nvPr/>
-        </p:nvSpPr>
-        <p:spPr>
-          <a:xfrm>
-            <a:off x="5257800" y="1737360"/>
-            <a:ext cx="3108960" cy="3429000"/>
-          </a:xfrm>
-          <a:prstGeom prst="rect">
-            <a:avLst/>
-          </a:prstGeom>
-          <a:noFill/>
-        </p:spPr>
-        <p:txBody>
-          <a:bodyPr wrap="square" anchor="t" lIns="0" rIns="0" tIns="0" bIns="0">
-            <a:spAutoFit/>
-          </a:bodyPr>
-          <a:lstStyle/>
-          <a:p>
-            <a:pPr marL="228600" indent="-228600">
-              <a:spcAft>
-                <a:spcPts val="900"/>
-              </a:spcAft>
-              <a:buFont typeface="Arial"/>
-              <a:buChar char="•"/>
-            </a:pPr>
-            <a:r>
-              <a:rPr sz="1700">
-                <a:solidFill>
-                  <a:srgbClr val="26323F"/>
-                </a:solidFill>
-                <a:latin typeface="Times New Roman"/>
-              </a:rPr>
-              <a:t>Labelled dataset: 2,000 reviews, 3,548 aspect annotations</a:t>
-            </a:r>
-          </a:p>
-          <a:p>
-            <a:pPr marL="228600" indent="-228600">
-              <a:spcAft>
-                <a:spcPts val="900"/>
-              </a:spcAft>
-              <a:buFont typeface="Arial"/>
-              <a:buChar char="•"/>
-            </a:pPr>
-            <a:r>
-              <a:rPr sz="1700">
-                <a:solidFill>
-                  <a:srgbClr val="26323F"/>
-                </a:solidFill>
-                <a:latin typeface="Times New Roman"/>
-              </a:rPr>
-              <a:t>Reproducible Python code (pushed to GitHub)</a:t>
-            </a:r>
-          </a:p>
-          <a:p>
-            <a:pPr marL="228600" indent="-228600">
-              <a:spcAft>
-                <a:spcPts val="900"/>
-              </a:spcAft>
-              <a:buFont typeface="Arial"/>
-              <a:buChar char="•"/>
-            </a:pPr>
-            <a:r>
-              <a:rPr sz="1700">
-                <a:solidFill>
-                  <a:srgbClr val="26323F"/>
-                </a:solidFill>
-                <a:latin typeface="Times New Roman"/>
-              </a:rPr>
-              <a:t>Nine-aspect taxonomy for refurbished electronics</a:t>
-            </a:r>
-          </a:p>
-          <a:p>
-            <a:pPr marL="228600" indent="-228600">
-              <a:spcAft>
-                <a:spcPts val="900"/>
-              </a:spcAft>
-              <a:buFont typeface="Arial"/>
-              <a:buChar char="•"/>
-            </a:pPr>
-            <a:r>
-              <a:rPr sz="1700">
-                <a:solidFill>
-                  <a:srgbClr val="26323F"/>
-                </a:solidFill>
-                <a:latin typeface="Times New Roman"/>
-              </a:rPr>
-              <a:t>Four-model comparison on a common leak-free protocol</a:t>
-            </a:r>
-          </a:p>
-        </p:txBody>
-      </p:sp>
-      <p:sp>
-        <p:nvSpPr>
-          <p:cNvPr id="13" name="Draft title strip"/>
-          <p:cNvSpPr/>
-          <p:nvPr/>
-        </p:nvSpPr>
-        <p:spPr>
-          <a:xfrm>
-            <a:off x="365760" y="5394960"/>
-            <a:ext cx="8229600" cy="868680"/>
-          </a:xfrm>
-          <a:prstGeom prst="roundRect">
-            <a:avLst>
-              <a:gd name="adj" fmla="val 8000"/>
-            </a:avLst>
-          </a:prstGeom>
-          <a:solidFill>
-            <a:srgbClr val="E6EFF8"/>
-          </a:solidFill>
-          <a:ln w="12700">
-            <a:solidFill>
-              <a:srgbClr val="9DB7C9"/>
-            </a:solidFill>
-          </a:ln>
-          <a:effectLst/>
-        </p:spPr>
-        <p:style>
-          <a:lnRef idx="1">
-            <a:schemeClr val="accent1"/>
-          </a:lnRef>
-          <a:fillRef idx="3">
-            <a:schemeClr val="accent1"/>
-          </a:fillRef>
-          <a:effectRef idx="2">
-            <a:schemeClr val="accent1"/>
-          </a:effectRef>
-          <a:fontRef idx="minor">
-            <a:schemeClr val="lt1"/>
-          </a:fontRef>
-        </p:style>
-        <p:txBody>
-          <a:bodyPr rtlCol="0" anchor="ctr"/>
-          <a:lstStyle/>
-          <a:p>
-            <a:pPr algn="ctr"/>
-          </a:p>
-        </p:txBody>
-      </p:sp>
-      <p:sp>
-        <p:nvSpPr>
-          <p:cNvPr id="14" name="Draft title text"/>
-          <p:cNvSpPr txBox="1"/>
-          <p:nvPr/>
-        </p:nvSpPr>
-        <p:spPr>
-          <a:xfrm>
-            <a:off x="594360" y="5440680"/>
-            <a:ext cx="7772400" cy="777240"/>
-          </a:xfrm>
-          <a:prstGeom prst="rect">
-            <a:avLst/>
-          </a:prstGeom>
-          <a:noFill/>
-        </p:spPr>
-        <p:txBody>
-          <a:bodyPr wrap="square" anchor="ctr" lIns="0" rIns="0" tIns="0" bIns="0">
-            <a:spAutoFit/>
-          </a:bodyPr>
-          <a:lstStyle/>
-          <a:p>
-            <a:pPr algn="l"/>
-            <a:r>
-              <a:rPr sz="1400" b="1">
-                <a:solidFill>
-                  <a:srgbClr val="1F3864"/>
-                </a:solidFill>
-                <a:latin typeface="Times New Roman"/>
-              </a:rPr>
-              <a:t>Paper title: RefurbIQ: Aspect-Based Sentiment Analysis of Refurbished Electronics Across Indian Marketplaces - draft in progress.</a:t>
-            </a:r>
-          </a:p>
-        </p:txBody>
-      </p:sp>
-    </p:spTree>
-  </p:cSld>
-  <p:clrMapOvr>
-    <a:masterClrMapping/>
-  </p:clrMapOvr>
-</p:sld>
-</file>
-
-<file path=ppt/slides/slide17.xml><?xml version="1.0" encoding="utf-8"?>
-<p:sld xmlns:a="http://schemas.openxmlformats.org/drawingml/2006/main" xmlns:p="http://schemas.openxmlformats.org/presentationml/2006/main" xmlns:r="http://schemas.openxmlformats.org/officeDocument/2006/relationships">
-  <p:cSld>
-    <p:bg>
-      <p:bgPr>
-        <a:blipFill>
-          <a:blip r:embed="rId2"/>
-          <a:tile tx="0" ty="0" sx="100000" sy="100000" flip="none" algn="tl"/>
-        </a:blipFill>
-        <a:effectLst/>
-      </p:bgPr>
-    </p:bg>
-    <p:spTree>
-      <p:nvGrpSpPr>
-        <p:cNvPr id="1" name=""/>
-        <p:cNvGrpSpPr/>
-        <p:nvPr/>
-      </p:nvGrpSpPr>
-      <p:grpSpPr/>
-      <p:sp>
-        <p:nvSpPr>
-          <p:cNvPr id="2" name="Title 1"/>
-          <p:cNvSpPr>
-            <a:spLocks noGrp="1"/>
-          </p:cNvSpPr>
-          <p:nvPr>
-            <p:ph type="title"/>
-          </p:nvPr>
-        </p:nvSpPr>
-        <p:spPr>
-          <a:xfrm>
-            <a:off x="446314" y="122238"/>
-            <a:ext cx="8229600" cy="868362"/>
-          </a:xfrm>
-          <a:prstGeom prst="roundRect">
-            <a:avLst/>
-          </a:prstGeom>
-          <a:solidFill>
-            <a:srgbClr val="E6EFF4"/>
-          </a:solidFill>
-          <a:ln w="19050">
-            <a:solidFill>
-              <a:srgbClr val="FFFFFF"/>
-            </a:solidFill>
-          </a:ln>
-        </p:spPr>
-        <p:txBody>
-          <a:bodyPr anchor="ctr"/>
-          <a:lstStyle/>
-          <a:p>
-            <a:pPr algn="ctr"/>
-            <a:r>
-              <a:rPr sz="3000" b="1">
-                <a:solidFill>
-                  <a:srgbClr val="1F3864"/>
-                </a:solidFill>
-                <a:latin typeface="Times New Roman"/>
-              </a:rPr>
-              <a:t>References</a:t>
-            </a:r>
-          </a:p>
-        </p:txBody>
-      </p:sp>
-      <p:sp>
-        <p:nvSpPr>
-          <p:cNvPr id="6" name="Slide Number Placeholder 5">
-            <a:extLst>
-              <a:ext uri="{FF2B5EF4-FFF2-40B4-BE49-F238E27FC236}">
-                <a16:creationId xmlns:a16="http://schemas.microsoft.com/office/drawing/2014/main" id="{B0CEE340-DD05-ABF3-E2C1-1FCA7E601094}"/>
-              </a:ext>
-            </a:extLst>
-          </p:cNvPr>
-          <p:cNvSpPr>
-            <a:spLocks noGrp="1"/>
-          </p:cNvSpPr>
-          <p:nvPr>
-            <p:ph type="sldNum" sz="quarter" idx="12"/>
-          </p:nvPr>
-        </p:nvSpPr>
-        <p:spPr/>
-        <p:txBody>
-          <a:bodyPr/>
-          <a:lstStyle/>
-          <a:p>
-            <a:fld id="{D0D3D9D9-2323-4B14-959B-DD5C508B8A7B}" type="slidenum">
-              <a:rPr lang="en-US" b="1" smtClean="0"/>
-              <a:pPr/>
-              <a:t>1</a:t>
-            </a:fld>
-            <a:endParaRPr lang="en-US" b="1" dirty="0"/>
-          </a:p>
-        </p:txBody>
-      </p:sp>
-      <p:sp>
-        <p:nvSpPr>
-          <p:cNvPr id="7" name="Reference card 1"/>
-          <p:cNvSpPr/>
-          <p:nvPr/>
-        </p:nvSpPr>
-        <p:spPr>
-          <a:xfrm>
-            <a:off x="365760" y="1188720"/>
-            <a:ext cx="8229600" cy="548640"/>
-          </a:xfrm>
-          <a:prstGeom prst="roundRect">
-            <a:avLst>
-              <a:gd name="adj" fmla="val 8000"/>
-            </a:avLst>
-          </a:prstGeom>
-          <a:solidFill>
-            <a:srgbClr val="FFFFFF"/>
-          </a:solidFill>
-          <a:ln w="12700">
-            <a:solidFill>
-              <a:srgbClr val="9DB7C9"/>
-            </a:solidFill>
-          </a:ln>
-          <a:effectLst/>
-        </p:spPr>
-        <p:style>
-          <a:lnRef idx="1">
-            <a:schemeClr val="accent1"/>
-          </a:lnRef>
-          <a:fillRef idx="3">
-            <a:schemeClr val="accent1"/>
-          </a:fillRef>
-          <a:effectRef idx="2">
-            <a:schemeClr val="accent1"/>
-          </a:effectRef>
-          <a:fontRef idx="minor">
-            <a:schemeClr val="lt1"/>
-          </a:fontRef>
-        </p:style>
-        <p:txBody>
-          <a:bodyPr rtlCol="0" anchor="ctr"/>
-          <a:lstStyle/>
-          <a:p>
-            <a:pPr algn="ctr"/>
-          </a:p>
-        </p:txBody>
-      </p:sp>
-      <p:sp>
-        <p:nvSpPr>
-          <p:cNvPr id="8" name="Reference id 1"/>
-          <p:cNvSpPr txBox="1"/>
-          <p:nvPr/>
-        </p:nvSpPr>
-        <p:spPr>
-          <a:xfrm>
-            <a:off x="502920" y="1216152"/>
-            <a:ext cx="685800" cy="493776"/>
-          </a:xfrm>
-          <a:prstGeom prst="rect">
-            <a:avLst/>
-          </a:prstGeom>
-          <a:noFill/>
-        </p:spPr>
-        <p:txBody>
-          <a:bodyPr wrap="square" anchor="ctr" lIns="0" rIns="0" tIns="0" bIns="0">
-            <a:spAutoFit/>
-          </a:bodyPr>
-          <a:lstStyle/>
-          <a:p>
-            <a:pPr algn="l"/>
-            <a:r>
-              <a:rPr sz="1400" b="1">
-                <a:solidFill>
-                  <a:srgbClr val="1F6F78"/>
-                </a:solidFill>
-                <a:latin typeface="Times New Roman"/>
-              </a:rPr>
-              <a:t>[1]</a:t>
-            </a:r>
-          </a:p>
-        </p:txBody>
-      </p:sp>
-      <p:sp>
-        <p:nvSpPr>
-          <p:cNvPr id="9" name="Reference text 1"/>
-          <p:cNvSpPr txBox="1"/>
-          <p:nvPr/>
-        </p:nvSpPr>
-        <p:spPr>
-          <a:xfrm>
-            <a:off x="1234440" y="1216152"/>
-            <a:ext cx="7269480" cy="493776"/>
-          </a:xfrm>
-          <a:prstGeom prst="rect">
-            <a:avLst/>
-          </a:prstGeom>
-          <a:noFill/>
-        </p:spPr>
-        <p:txBody>
-          <a:bodyPr wrap="square" anchor="ctr" lIns="0" rIns="0" tIns="0" bIns="0">
-            <a:spAutoFit/>
-          </a:bodyPr>
-          <a:lstStyle/>
-          <a:p>
-            <a:pPr algn="l"/>
-            <a:r>
-              <a:rPr sz="1300">
-                <a:solidFill>
-                  <a:srgbClr val="26323F"/>
-                </a:solidFill>
-                <a:latin typeface="Times New Roman"/>
-              </a:rPr>
-              <a:t>A. Chevalier and M. Mayzlin, “The effect of word of mouth on sales: Online book reviews,” J. Marketing Research, vol. 43, no. 3, pp. 345–354, 2006.</a:t>
-            </a:r>
-          </a:p>
-        </p:txBody>
-      </p:sp>
-      <p:sp>
-        <p:nvSpPr>
-          <p:cNvPr id="10" name="Reference card 2"/>
-          <p:cNvSpPr/>
-          <p:nvPr/>
-        </p:nvSpPr>
-        <p:spPr>
-          <a:xfrm>
-            <a:off x="365760" y="1792224"/>
-            <a:ext cx="8229600" cy="731520"/>
-          </a:xfrm>
-          <a:prstGeom prst="roundRect">
-            <a:avLst>
-              <a:gd name="adj" fmla="val 8000"/>
-            </a:avLst>
-          </a:prstGeom>
-          <a:solidFill>
-            <a:srgbClr val="FFFFFF"/>
-          </a:solidFill>
-          <a:ln w="12700">
-            <a:solidFill>
-              <a:srgbClr val="9DB7C9"/>
-            </a:solidFill>
-          </a:ln>
-          <a:effectLst/>
-        </p:spPr>
-        <p:style>
-          <a:lnRef idx="1">
-            <a:schemeClr val="accent1"/>
-          </a:lnRef>
-          <a:fillRef idx="3">
-            <a:schemeClr val="accent1"/>
-          </a:fillRef>
-          <a:effectRef idx="2">
-            <a:schemeClr val="accent1"/>
-          </a:effectRef>
-          <a:fontRef idx="minor">
-            <a:schemeClr val="lt1"/>
-          </a:fontRef>
-        </p:style>
-        <p:txBody>
-          <a:bodyPr rtlCol="0" anchor="ctr"/>
-          <a:lstStyle/>
-          <a:p>
-            <a:pPr algn="ctr"/>
-          </a:p>
-        </p:txBody>
-      </p:sp>
-      <p:sp>
-        <p:nvSpPr>
-          <p:cNvPr id="11" name="Reference id 2"/>
-          <p:cNvSpPr txBox="1"/>
-          <p:nvPr/>
-        </p:nvSpPr>
-        <p:spPr>
-          <a:xfrm>
-            <a:off x="502920" y="1819656"/>
-            <a:ext cx="685800" cy="676656"/>
-          </a:xfrm>
-          <a:prstGeom prst="rect">
-            <a:avLst/>
-          </a:prstGeom>
-          <a:noFill/>
-        </p:spPr>
-        <p:txBody>
-          <a:bodyPr wrap="square" anchor="ctr" lIns="0" rIns="0" tIns="0" bIns="0">
-            <a:spAutoFit/>
-          </a:bodyPr>
-          <a:lstStyle/>
-          <a:p>
-            <a:pPr algn="l"/>
-            <a:r>
-              <a:rPr sz="1400" b="1">
-                <a:solidFill>
-                  <a:srgbClr val="1F6F78"/>
-                </a:solidFill>
-                <a:latin typeface="Times New Roman"/>
-              </a:rPr>
-              <a:t>[2]</a:t>
-            </a:r>
-          </a:p>
-        </p:txBody>
-      </p:sp>
-      <p:sp>
-        <p:nvSpPr>
-          <p:cNvPr id="12" name="Reference text 2"/>
-          <p:cNvSpPr txBox="1"/>
-          <p:nvPr/>
-        </p:nvSpPr>
-        <p:spPr>
-          <a:xfrm>
-            <a:off x="1234440" y="1819656"/>
-            <a:ext cx="7269480" cy="676656"/>
-          </a:xfrm>
-          <a:prstGeom prst="rect">
-            <a:avLst/>
-          </a:prstGeom>
-          <a:noFill/>
-        </p:spPr>
-        <p:txBody>
-          <a:bodyPr wrap="square" anchor="ctr" lIns="0" rIns="0" tIns="0" bIns="0">
-            <a:spAutoFit/>
-          </a:bodyPr>
-          <a:lstStyle/>
-          <a:p>
-            <a:pPr algn="l"/>
-            <a:r>
-              <a:rPr sz="1300">
-                <a:solidFill>
-                  <a:srgbClr val="26323F"/>
-                </a:solidFill>
-                <a:latin typeface="Times New Roman"/>
-              </a:rPr>
-              <a:t>B. Liu, Sentiment Analysis and Opinion Mining. Morgan &amp; Claypool, 2012.</a:t>
-            </a:r>
-          </a:p>
-        </p:txBody>
-      </p:sp>
-      <p:sp>
-        <p:nvSpPr>
-          <p:cNvPr id="13" name="Reference card 3"/>
-          <p:cNvSpPr/>
-          <p:nvPr/>
-        </p:nvSpPr>
-        <p:spPr>
-          <a:xfrm>
-            <a:off x="365760" y="2578608"/>
-            <a:ext cx="8229600" cy="548640"/>
-          </a:xfrm>
-          <a:prstGeom prst="roundRect">
-            <a:avLst>
-              <a:gd name="adj" fmla="val 8000"/>
-            </a:avLst>
-          </a:prstGeom>
-          <a:solidFill>
-            <a:srgbClr val="FFFFFF"/>
-          </a:solidFill>
-          <a:ln w="12700">
-            <a:solidFill>
-              <a:srgbClr val="9DB7C9"/>
-            </a:solidFill>
-          </a:ln>
-          <a:effectLst/>
-        </p:spPr>
-        <p:style>
-          <a:lnRef idx="1">
-            <a:schemeClr val="accent1"/>
-          </a:lnRef>
-          <a:fillRef idx="3">
-            <a:schemeClr val="accent1"/>
-          </a:fillRef>
-          <a:effectRef idx="2">
-            <a:schemeClr val="accent1"/>
-          </a:effectRef>
-          <a:fontRef idx="minor">
-            <a:schemeClr val="lt1"/>
-          </a:fontRef>
-        </p:style>
-        <p:txBody>
-          <a:bodyPr rtlCol="0" anchor="ctr"/>
-          <a:lstStyle/>
-          <a:p>
-            <a:pPr algn="ctr"/>
-          </a:p>
-        </p:txBody>
-      </p:sp>
-      <p:sp>
-        <p:nvSpPr>
-          <p:cNvPr id="14" name="Reference id 3"/>
-          <p:cNvSpPr txBox="1"/>
-          <p:nvPr/>
-        </p:nvSpPr>
-        <p:spPr>
-          <a:xfrm>
-            <a:off x="502920" y="2606040"/>
-            <a:ext cx="685800" cy="493776"/>
-          </a:xfrm>
-          <a:prstGeom prst="rect">
-            <a:avLst/>
-          </a:prstGeom>
-          <a:noFill/>
-        </p:spPr>
-        <p:txBody>
-          <a:bodyPr wrap="square" anchor="ctr" lIns="0" rIns="0" tIns="0" bIns="0">
-            <a:spAutoFit/>
-          </a:bodyPr>
-          <a:lstStyle/>
-          <a:p>
-            <a:pPr algn="l"/>
-            <a:r>
-              <a:rPr sz="1400" b="1">
-                <a:solidFill>
-                  <a:srgbClr val="1F6F78"/>
-                </a:solidFill>
-                <a:latin typeface="Times New Roman"/>
-              </a:rPr>
-              <a:t>[3]</a:t>
-            </a:r>
-          </a:p>
-        </p:txBody>
-      </p:sp>
-      <p:sp>
-        <p:nvSpPr>
-          <p:cNvPr id="15" name="Reference text 3"/>
-          <p:cNvSpPr txBox="1"/>
-          <p:nvPr/>
-        </p:nvSpPr>
-        <p:spPr>
-          <a:xfrm>
-            <a:off x="1234440" y="2606040"/>
-            <a:ext cx="7269480" cy="493776"/>
-          </a:xfrm>
-          <a:prstGeom prst="rect">
-            <a:avLst/>
-          </a:prstGeom>
-          <a:noFill/>
-        </p:spPr>
-        <p:txBody>
-          <a:bodyPr wrap="square" anchor="ctr" lIns="0" rIns="0" tIns="0" bIns="0">
-            <a:spAutoFit/>
-          </a:bodyPr>
-          <a:lstStyle/>
-          <a:p>
-            <a:pPr algn="l"/>
-            <a:r>
-              <a:rPr sz="1300">
-                <a:solidFill>
-                  <a:srgbClr val="26323F"/>
-                </a:solidFill>
-                <a:latin typeface="Times New Roman"/>
-              </a:rPr>
-              <a:t>B. Pang and L. Lee, “Opinion mining and sentiment analysis,” Foundations and Trends in Information Retrieval, vol. 2, no. 1–2, pp. 1–135, 2008.</a:t>
-            </a:r>
-          </a:p>
-        </p:txBody>
-      </p:sp>
-      <p:sp>
-        <p:nvSpPr>
-          <p:cNvPr id="16" name="Reference card 4"/>
-          <p:cNvSpPr/>
-          <p:nvPr/>
-        </p:nvSpPr>
-        <p:spPr>
-          <a:xfrm>
-            <a:off x="365760" y="3182112"/>
-            <a:ext cx="8229600" cy="457200"/>
-          </a:xfrm>
-          <a:prstGeom prst="roundRect">
-            <a:avLst>
-              <a:gd name="adj" fmla="val 8000"/>
-            </a:avLst>
-          </a:prstGeom>
-          <a:solidFill>
-            <a:srgbClr val="FFFFFF"/>
-          </a:solidFill>
-          <a:ln w="12700">
-            <a:solidFill>
-              <a:srgbClr val="9DB7C9"/>
-            </a:solidFill>
-          </a:ln>
-          <a:effectLst/>
-        </p:spPr>
-        <p:style>
-          <a:lnRef idx="1">
-            <a:schemeClr val="accent1"/>
-          </a:lnRef>
-          <a:fillRef idx="3">
-            <a:schemeClr val="accent1"/>
-          </a:fillRef>
-          <a:effectRef idx="2">
-            <a:schemeClr val="accent1"/>
-          </a:effectRef>
-          <a:fontRef idx="minor">
-            <a:schemeClr val="lt1"/>
-          </a:fontRef>
-        </p:style>
-        <p:txBody>
-          <a:bodyPr rtlCol="0" anchor="ctr"/>
-          <a:lstStyle/>
-          <a:p>
-            <a:pPr algn="ctr"/>
-          </a:p>
-        </p:txBody>
-      </p:sp>
-      <p:sp>
-        <p:nvSpPr>
-          <p:cNvPr id="17" name="Reference id 4"/>
-          <p:cNvSpPr txBox="1"/>
-          <p:nvPr/>
-        </p:nvSpPr>
-        <p:spPr>
-          <a:xfrm>
-            <a:off x="502920" y="3209544"/>
-            <a:ext cx="685800" cy="402336"/>
-          </a:xfrm>
-          <a:prstGeom prst="rect">
-            <a:avLst/>
-          </a:prstGeom>
-          <a:noFill/>
-        </p:spPr>
-        <p:txBody>
-          <a:bodyPr wrap="square" anchor="ctr" lIns="0" rIns="0" tIns="0" bIns="0">
-            <a:spAutoFit/>
-          </a:bodyPr>
-          <a:lstStyle/>
-          <a:p>
-            <a:pPr algn="l"/>
-            <a:r>
-              <a:rPr sz="1400" b="1">
-                <a:solidFill>
-                  <a:srgbClr val="1F6F78"/>
-                </a:solidFill>
-                <a:latin typeface="Times New Roman"/>
-              </a:rPr>
-              <a:t>[4]</a:t>
-            </a:r>
-          </a:p>
-        </p:txBody>
-      </p:sp>
-      <p:sp>
-        <p:nvSpPr>
-          <p:cNvPr id="18" name="Reference text 4"/>
-          <p:cNvSpPr txBox="1"/>
-          <p:nvPr/>
-        </p:nvSpPr>
-        <p:spPr>
-          <a:xfrm>
-            <a:off x="1234440" y="3209544"/>
-            <a:ext cx="7269480" cy="402336"/>
-          </a:xfrm>
-          <a:prstGeom prst="rect">
-            <a:avLst/>
-          </a:prstGeom>
-          <a:noFill/>
-        </p:spPr>
-        <p:txBody>
-          <a:bodyPr wrap="square" anchor="ctr" lIns="0" rIns="0" tIns="0" bIns="0">
-            <a:spAutoFit/>
-          </a:bodyPr>
-          <a:lstStyle/>
-          <a:p>
-            <a:pPr algn="l"/>
-            <a:r>
-              <a:rPr sz="1300">
-                <a:solidFill>
-                  <a:srgbClr val="26323F"/>
-                </a:solidFill>
-                <a:latin typeface="Times New Roman"/>
-              </a:rPr>
-              <a:t>M. Hu and B. Liu, “Mining and summarizing customer reviews,” in Proc. KDD, 2004, pp. 168–177.</a:t>
-            </a:r>
-          </a:p>
-        </p:txBody>
-      </p:sp>
-      <p:sp>
-        <p:nvSpPr>
-          <p:cNvPr id="19" name="Reference card 5"/>
-          <p:cNvSpPr/>
-          <p:nvPr/>
-        </p:nvSpPr>
-        <p:spPr>
-          <a:xfrm>
-            <a:off x="365760" y="3694176"/>
-            <a:ext cx="8229600" cy="594360"/>
-          </a:xfrm>
-          <a:prstGeom prst="roundRect">
-            <a:avLst>
-              <a:gd name="adj" fmla="val 8000"/>
-            </a:avLst>
-          </a:prstGeom>
-          <a:solidFill>
-            <a:srgbClr val="FFFFFF"/>
-          </a:solidFill>
-          <a:ln w="12700">
-            <a:solidFill>
-              <a:srgbClr val="9DB7C9"/>
-            </a:solidFill>
-          </a:ln>
-          <a:effectLst/>
-        </p:spPr>
-        <p:style>
-          <a:lnRef idx="1">
-            <a:schemeClr val="accent1"/>
-          </a:lnRef>
-          <a:fillRef idx="3">
-            <a:schemeClr val="accent1"/>
-          </a:fillRef>
-          <a:effectRef idx="2">
-            <a:schemeClr val="accent1"/>
-          </a:effectRef>
-          <a:fontRef idx="minor">
-            <a:schemeClr val="lt1"/>
-          </a:fontRef>
-        </p:style>
-        <p:txBody>
-          <a:bodyPr rtlCol="0" anchor="ctr"/>
-          <a:lstStyle/>
-          <a:p>
-            <a:pPr algn="ctr"/>
-          </a:p>
-        </p:txBody>
-      </p:sp>
-      <p:sp>
-        <p:nvSpPr>
-          <p:cNvPr id="20" name="Reference id 5"/>
-          <p:cNvSpPr txBox="1"/>
-          <p:nvPr/>
-        </p:nvSpPr>
-        <p:spPr>
-          <a:xfrm>
-            <a:off x="502920" y="3721608"/>
-            <a:ext cx="685800" cy="539496"/>
-          </a:xfrm>
-          <a:prstGeom prst="rect">
-            <a:avLst/>
-          </a:prstGeom>
-          <a:noFill/>
-        </p:spPr>
-        <p:txBody>
-          <a:bodyPr wrap="square" anchor="ctr" lIns="0" rIns="0" tIns="0" bIns="0">
-            <a:spAutoFit/>
-          </a:bodyPr>
-          <a:lstStyle/>
-          <a:p>
-            <a:pPr algn="l"/>
-            <a:r>
-              <a:rPr sz="1400" b="1">
-                <a:solidFill>
-                  <a:srgbClr val="1F6F78"/>
-                </a:solidFill>
-                <a:latin typeface="Times New Roman"/>
-              </a:rPr>
-              <a:t>[5]</a:t>
-            </a:r>
-          </a:p>
-        </p:txBody>
-      </p:sp>
-      <p:sp>
-        <p:nvSpPr>
-          <p:cNvPr id="21" name="Reference text 5"/>
-          <p:cNvSpPr txBox="1"/>
-          <p:nvPr/>
-        </p:nvSpPr>
-        <p:spPr>
-          <a:xfrm>
-            <a:off x="1234440" y="3721608"/>
-            <a:ext cx="7269480" cy="539496"/>
-          </a:xfrm>
-          <a:prstGeom prst="rect">
-            <a:avLst/>
-          </a:prstGeom>
-          <a:noFill/>
-        </p:spPr>
-        <p:txBody>
-          <a:bodyPr wrap="square" anchor="ctr" lIns="0" rIns="0" tIns="0" bIns="0">
-            <a:spAutoFit/>
-          </a:bodyPr>
-          <a:lstStyle/>
-          <a:p>
-            <a:pPr algn="l"/>
-            <a:r>
-              <a:rPr sz="1300">
-                <a:solidFill>
-                  <a:srgbClr val="26323F"/>
-                </a:solidFill>
-                <a:latin typeface="Times New Roman"/>
-              </a:rPr>
-              <a:t>M. Pontiki et al., “SemEval-2014 Task 4: Aspect based sentiment analysis,” in Proc. SemEval, 2014, pp. 27–35.</a:t>
-            </a:r>
-          </a:p>
-        </p:txBody>
-      </p:sp>
-      <p:sp>
-        <p:nvSpPr>
-          <p:cNvPr id="22" name="Reference card 6"/>
-          <p:cNvSpPr/>
-          <p:nvPr/>
-        </p:nvSpPr>
-        <p:spPr>
-          <a:xfrm>
-            <a:off x="365760" y="4343400"/>
-            <a:ext cx="8229600" cy="548640"/>
-          </a:xfrm>
-          <a:prstGeom prst="roundRect">
-            <a:avLst>
-              <a:gd name="adj" fmla="val 8000"/>
-            </a:avLst>
-          </a:prstGeom>
-          <a:solidFill>
-            <a:srgbClr val="FFFFFF"/>
-          </a:solidFill>
-          <a:ln w="12700">
-            <a:solidFill>
-              <a:srgbClr val="9DB7C9"/>
-            </a:solidFill>
-          </a:ln>
-          <a:effectLst/>
-        </p:spPr>
-        <p:style>
-          <a:lnRef idx="1">
-            <a:schemeClr val="accent1"/>
-          </a:lnRef>
-          <a:fillRef idx="3">
-            <a:schemeClr val="accent1"/>
-          </a:fillRef>
-          <a:effectRef idx="2">
-            <a:schemeClr val="accent1"/>
-          </a:effectRef>
-          <a:fontRef idx="minor">
-            <a:schemeClr val="lt1"/>
-          </a:fontRef>
-        </p:style>
-        <p:txBody>
-          <a:bodyPr rtlCol="0" anchor="ctr"/>
-          <a:lstStyle/>
-          <a:p>
-            <a:pPr algn="ctr"/>
-          </a:p>
-        </p:txBody>
-      </p:sp>
-      <p:sp>
-        <p:nvSpPr>
-          <p:cNvPr id="23" name="Reference id 6"/>
-          <p:cNvSpPr txBox="1"/>
-          <p:nvPr/>
-        </p:nvSpPr>
-        <p:spPr>
-          <a:xfrm>
-            <a:off x="502920" y="4370832"/>
-            <a:ext cx="685800" cy="493776"/>
-          </a:xfrm>
-          <a:prstGeom prst="rect">
-            <a:avLst/>
-          </a:prstGeom>
-          <a:noFill/>
-        </p:spPr>
-        <p:txBody>
-          <a:bodyPr wrap="square" anchor="ctr" lIns="0" rIns="0" tIns="0" bIns="0">
-            <a:spAutoFit/>
-          </a:bodyPr>
-          <a:lstStyle/>
-          <a:p>
-            <a:pPr algn="l"/>
-            <a:r>
-              <a:rPr sz="1400" b="1">
-                <a:solidFill>
-                  <a:srgbClr val="1F6F78"/>
-                </a:solidFill>
-                <a:latin typeface="Times New Roman"/>
-              </a:rPr>
-              <a:t>[6]</a:t>
-            </a:r>
-          </a:p>
-        </p:txBody>
-      </p:sp>
-      <p:sp>
-        <p:nvSpPr>
-          <p:cNvPr id="24" name="Reference text 6"/>
-          <p:cNvSpPr txBox="1"/>
-          <p:nvPr/>
-        </p:nvSpPr>
-        <p:spPr>
-          <a:xfrm>
-            <a:off x="1234440" y="4370832"/>
-            <a:ext cx="7269480" cy="493776"/>
-          </a:xfrm>
-          <a:prstGeom prst="rect">
-            <a:avLst/>
-          </a:prstGeom>
-          <a:noFill/>
-        </p:spPr>
-        <p:txBody>
-          <a:bodyPr wrap="square" anchor="ctr" lIns="0" rIns="0" tIns="0" bIns="0">
-            <a:spAutoFit/>
-          </a:bodyPr>
-          <a:lstStyle/>
-          <a:p>
-            <a:pPr algn="l"/>
-            <a:r>
-              <a:rPr sz="1300">
-                <a:solidFill>
-                  <a:srgbClr val="26323F"/>
-                </a:solidFill>
-                <a:latin typeface="Times New Roman"/>
-              </a:rPr>
-              <a:t>M. Pontiki et al., “SemEval-2016 Task 5: Aspect based sentiment analysis,” in Proc. SemEval, 2016, pp. 19–30.</a:t>
-            </a:r>
-          </a:p>
-        </p:txBody>
-      </p:sp>
-      <p:sp>
-        <p:nvSpPr>
-          <p:cNvPr id="25" name="Reference card 7"/>
-          <p:cNvSpPr/>
-          <p:nvPr/>
-        </p:nvSpPr>
-        <p:spPr>
-          <a:xfrm>
-            <a:off x="365760" y="4946904"/>
-            <a:ext cx="8229600" cy="594360"/>
-          </a:xfrm>
-          <a:prstGeom prst="roundRect">
-            <a:avLst>
-              <a:gd name="adj" fmla="val 8000"/>
-            </a:avLst>
-          </a:prstGeom>
-          <a:solidFill>
-            <a:srgbClr val="FFFFFF"/>
-          </a:solidFill>
-          <a:ln w="12700">
-            <a:solidFill>
-              <a:srgbClr val="9DB7C9"/>
-            </a:solidFill>
-          </a:ln>
-          <a:effectLst/>
-        </p:spPr>
-        <p:style>
-          <a:lnRef idx="1">
-            <a:schemeClr val="accent1"/>
-          </a:lnRef>
-          <a:fillRef idx="3">
-            <a:schemeClr val="accent1"/>
-          </a:fillRef>
-          <a:effectRef idx="2">
-            <a:schemeClr val="accent1"/>
-          </a:effectRef>
-          <a:fontRef idx="minor">
-            <a:schemeClr val="lt1"/>
-          </a:fontRef>
-        </p:style>
-        <p:txBody>
-          <a:bodyPr rtlCol="0" anchor="ctr"/>
-          <a:lstStyle/>
-          <a:p>
-            <a:pPr algn="ctr"/>
-          </a:p>
-        </p:txBody>
-      </p:sp>
-      <p:sp>
-        <p:nvSpPr>
-          <p:cNvPr id="26" name="Reference id 7"/>
-          <p:cNvSpPr txBox="1"/>
-          <p:nvPr/>
-        </p:nvSpPr>
-        <p:spPr>
-          <a:xfrm>
-            <a:off x="502920" y="4974336"/>
-            <a:ext cx="685800" cy="539496"/>
-          </a:xfrm>
-          <a:prstGeom prst="rect">
-            <a:avLst/>
-          </a:prstGeom>
-          <a:noFill/>
-        </p:spPr>
-        <p:txBody>
-          <a:bodyPr wrap="square" anchor="ctr" lIns="0" rIns="0" tIns="0" bIns="0">
-            <a:spAutoFit/>
-          </a:bodyPr>
-          <a:lstStyle/>
-          <a:p>
-            <a:pPr algn="l"/>
-            <a:r>
-              <a:rPr sz="1400" b="1">
-                <a:solidFill>
-                  <a:srgbClr val="1F6F78"/>
-                </a:solidFill>
-                <a:latin typeface="Times New Roman"/>
-              </a:rPr>
-              <a:t>[7]</a:t>
-            </a:r>
-          </a:p>
-        </p:txBody>
-      </p:sp>
-      <p:sp>
-        <p:nvSpPr>
-          <p:cNvPr id="27" name="Reference text 7"/>
-          <p:cNvSpPr txBox="1"/>
-          <p:nvPr/>
-        </p:nvSpPr>
-        <p:spPr>
-          <a:xfrm>
-            <a:off x="1234440" y="4974336"/>
-            <a:ext cx="7269480" cy="539496"/>
-          </a:xfrm>
-          <a:prstGeom prst="rect">
-            <a:avLst/>
-          </a:prstGeom>
-          <a:noFill/>
-        </p:spPr>
-        <p:txBody>
-          <a:bodyPr wrap="square" anchor="ctr" lIns="0" rIns="0" tIns="0" bIns="0">
-            <a:spAutoFit/>
-          </a:bodyPr>
-          <a:lstStyle/>
-          <a:p>
-            <a:pPr algn="l"/>
-            <a:r>
-              <a:rPr sz="1300">
-                <a:solidFill>
-                  <a:srgbClr val="26323F"/>
-                </a:solidFill>
-                <a:latin typeface="Times New Roman"/>
-              </a:rPr>
-              <a:t>A. Vaswani et al., “Attention is all you need,” in Proc. NeurIPS, 2017, pp. 5998–6008.</a:t>
-            </a:r>
-          </a:p>
-        </p:txBody>
-      </p:sp>
-      <p:sp>
-        <p:nvSpPr>
-          <p:cNvPr id="28" name="Reference card 8"/>
-          <p:cNvSpPr/>
-          <p:nvPr/>
-        </p:nvSpPr>
-        <p:spPr>
-          <a:xfrm>
-            <a:off x="365760" y="5596128"/>
-            <a:ext cx="8229600" cy="457200"/>
-          </a:xfrm>
-          <a:prstGeom prst="roundRect">
-            <a:avLst>
-              <a:gd name="adj" fmla="val 8000"/>
-            </a:avLst>
-          </a:prstGeom>
-          <a:solidFill>
-            <a:srgbClr val="FFFFFF"/>
-          </a:solidFill>
-          <a:ln w="12700">
-            <a:solidFill>
-              <a:srgbClr val="9DB7C9"/>
-            </a:solidFill>
-          </a:ln>
-          <a:effectLst/>
-        </p:spPr>
-        <p:style>
-          <a:lnRef idx="1">
-            <a:schemeClr val="accent1"/>
-          </a:lnRef>
-          <a:fillRef idx="3">
-            <a:schemeClr val="accent1"/>
-          </a:fillRef>
-          <a:effectRef idx="2">
-            <a:schemeClr val="accent1"/>
-          </a:effectRef>
-          <a:fontRef idx="minor">
-            <a:schemeClr val="lt1"/>
-          </a:fontRef>
-        </p:style>
-        <p:txBody>
-          <a:bodyPr rtlCol="0" anchor="ctr"/>
-          <a:lstStyle/>
-          <a:p>
-            <a:pPr algn="ctr"/>
-          </a:p>
-        </p:txBody>
-      </p:sp>
-      <p:sp>
-        <p:nvSpPr>
-          <p:cNvPr id="29" name="Reference id 8"/>
-          <p:cNvSpPr txBox="1"/>
-          <p:nvPr/>
-        </p:nvSpPr>
-        <p:spPr>
-          <a:xfrm>
-            <a:off x="502920" y="5623560"/>
-            <a:ext cx="685800" cy="402336"/>
-          </a:xfrm>
-          <a:prstGeom prst="rect">
-            <a:avLst/>
-          </a:prstGeom>
-          <a:noFill/>
-        </p:spPr>
-        <p:txBody>
-          <a:bodyPr wrap="square" anchor="ctr" lIns="0" rIns="0" tIns="0" bIns="0">
-            <a:spAutoFit/>
-          </a:bodyPr>
-          <a:lstStyle/>
-          <a:p>
-            <a:pPr algn="l"/>
-            <a:r>
-              <a:rPr sz="1400" b="1">
-                <a:solidFill>
-                  <a:srgbClr val="1F6F78"/>
-                </a:solidFill>
-                <a:latin typeface="Times New Roman"/>
-              </a:rPr>
-              <a:t>[8]</a:t>
-            </a:r>
-          </a:p>
-        </p:txBody>
-      </p:sp>
-      <p:sp>
-        <p:nvSpPr>
-          <p:cNvPr id="30" name="Reference text 8"/>
-          <p:cNvSpPr txBox="1"/>
-          <p:nvPr/>
-        </p:nvSpPr>
-        <p:spPr>
-          <a:xfrm>
-            <a:off x="1234440" y="5623560"/>
-            <a:ext cx="7269480" cy="402336"/>
-          </a:xfrm>
-          <a:prstGeom prst="rect">
-            <a:avLst/>
-          </a:prstGeom>
-          <a:noFill/>
-        </p:spPr>
-        <p:txBody>
-          <a:bodyPr wrap="square" anchor="ctr" lIns="0" rIns="0" tIns="0" bIns="0">
-            <a:spAutoFit/>
-          </a:bodyPr>
-          <a:lstStyle/>
-          <a:p>
-            <a:pPr algn="l"/>
-            <a:r>
-              <a:rPr sz="1300">
-                <a:solidFill>
-                  <a:srgbClr val="26323F"/>
-                </a:solidFill>
-                <a:latin typeface="Times New Roman"/>
-              </a:rPr>
-              <a:t>J. Devlin et al., “BERT: Pre-training of deep bidirectional transformers,” in Proc. NAACL-HLT, 2019, pp. 4171–4186.</a:t>
-            </a:r>
-          </a:p>
-        </p:txBody>
-      </p:sp>
-      <p:sp>
-        <p:nvSpPr>
-          <p:cNvPr id="31" name="Reference note"/>
-          <p:cNvSpPr txBox="1"/>
-          <p:nvPr/>
-        </p:nvSpPr>
-        <p:spPr>
-          <a:xfrm>
-            <a:off x="365760" y="6126480"/>
-            <a:ext cx="8229600" cy="365760"/>
-          </a:xfrm>
-          <a:prstGeom prst="rect">
-            <a:avLst/>
-          </a:prstGeom>
-          <a:noFill/>
-        </p:spPr>
-        <p:txBody>
-          <a:bodyPr wrap="square" anchor="t" lIns="0" rIns="0" tIns="0" bIns="0">
-            <a:spAutoFit/>
-          </a:bodyPr>
-          <a:lstStyle/>
-          <a:p>
-            <a:pPr algn="ctr"/>
-            <a:r>
-              <a:rPr sz="1300" i="1">
-                <a:solidFill>
-                  <a:srgbClr val="556575"/>
-                </a:solidFill>
-                <a:latin typeface="Times New Roman"/>
-              </a:rPr>
-              <a:t>These eight references are the only sources cited in this presentation.</a:t>
-            </a:r>
-          </a:p>
-        </p:txBody>
-      </p:sp>
-    </p:spTree>
-  </p:cSld>
-  <p:clrMapOvr>
-    <a:masterClrMapping/>
-  </p:clrMapOvr>
-</p:sld>
-</file>
-
 <file path=ppt/slides/slide18.xml><?xml version="1.0" encoding="utf-8"?>
 <p:sld xmlns:a="http://schemas.openxmlformats.org/drawingml/2006/main" xmlns:p="http://schemas.openxmlformats.org/presentationml/2006/main" xmlns:r="http://schemas.openxmlformats.org/officeDocument/2006/relationships">
   <p:cSld>
@@ -17934,14 +16454,14 @@
                 </a:solidFill>
                 <a:latin typeface="Times New Roman"/>
               </a:rPr>
-              <a:t>Methodology: Pipeline Overview</a:t>
+              <a:t>System Design: App Workflow</a:t>
             </a:r>
           </a:p>
         </p:txBody>
       </p:sp>
       <p:pic>
         <p:nvPicPr>
-          <p:cNvPr id="3" name="Picture 2" descr="3_diagram_research_pipeline.png"/>
+          <p:cNvPr id="3" name="Picture 2" descr="2_diagram_app_workflow.png"/>
           <p:cNvPicPr>
             <a:picLocks noChangeAspect="1"/>
           </p:cNvPicPr>
@@ -17955,8 +16475,8 @@
         </p:blipFill>
         <p:spPr>
           <a:xfrm>
-            <a:off x="987292" y="1133856"/>
-            <a:ext cx="7169414" cy="5138927"/>
+            <a:off x="670767" y="1133856"/>
+            <a:ext cx="7802464" cy="5138928"/>
           </a:xfrm>
           <a:prstGeom prst="rect">
             <a:avLst/>
@@ -18004,14 +16524,14 @@
                 </a:solidFill>
                 <a:latin typeface="Times New Roman"/>
               </a:rPr>
-              <a:t>Technology Stack</a:t>
+              <a:t>Recommendation Engine</a:t>
             </a:r>
           </a:p>
         </p:txBody>
       </p:sp>
       <p:pic>
         <p:nvPicPr>
-          <p:cNvPr id="3" name="Picture 2" descr="1_diagram_tech_stack.png"/>
+          <p:cNvPr id="3" name="Picture 2" descr="4_diagram_recommendation.png"/>
           <p:cNvPicPr>
             <a:picLocks noChangeAspect="1"/>
           </p:cNvPicPr>
@@ -18025,8 +16545,8 @@
         </p:blipFill>
         <p:spPr>
           <a:xfrm>
-            <a:off x="755696" y="1133856"/>
-            <a:ext cx="7632607" cy="5138928"/>
+            <a:off x="492107" y="1133856"/>
+            <a:ext cx="8159784" cy="5138928"/>
           </a:xfrm>
           <a:prstGeom prst="rect">
             <a:avLst/>
@@ -18127,6 +16647,15 @@
 <file path=ppt/slides/slide20.xml><?xml version="1.0" encoding="utf-8"?>
 <p:sld xmlns:a="http://schemas.openxmlformats.org/drawingml/2006/main" xmlns:p="http://schemas.openxmlformats.org/presentationml/2006/main" xmlns:r="http://schemas.openxmlformats.org/officeDocument/2006/relationships">
   <p:cSld>
+    <p:bg>
+      <p:bgPr>
+        <a:blipFill>
+          <a:blip r:embed="rId2"/>
+          <a:tile tx="0" ty="0" sx="100000" sy="100000" flip="none" algn="tl"/>
+        </a:blipFill>
+        <a:effectLst/>
+      </p:bgPr>
+    </p:bg>
     <p:spTree>
       <p:nvGrpSpPr>
         <p:cNvPr id="1" name=""/>
@@ -18144,9 +16673,25 @@
             <p:ph type="title"/>
           </p:nvPr>
         </p:nvSpPr>
-        <p:spPr/>
-        <p:txBody>
-          <a:bodyPr/>
+        <p:spPr>
+          <a:xfrm>
+            <a:off x="446314" y="122238"/>
+            <a:ext cx="8229600" cy="868362"/>
+          </a:xfrm>
+          <a:prstGeom prst="roundRect">
+            <a:avLst/>
+          </a:prstGeom>
+          <a:solidFill>
+            <a:srgbClr val="E6EFF4"/>
+          </a:solidFill>
+          <a:ln w="19050">
+            <a:solidFill>
+              <a:srgbClr val="FFFFFF"/>
+            </a:solidFill>
+          </a:ln>
+        </p:spPr>
+        <p:txBody>
+          <a:bodyPr anchor="ctr"/>
           <a:lstStyle/>
           <a:p>
             <a:pPr algn="ctr"/>
@@ -18157,35 +16702,480 @@
                 </a:solidFill>
                 <a:latin typeface="Times New Roman"/>
               </a:rPr>
-              <a:t>System Design: App Workflow</a:t>
-            </a:r>
-          </a:p>
-        </p:txBody>
-      </p:sp>
-      <p:pic>
-        <p:nvPicPr>
-          <p:cNvPr id="3" name="Picture 2" descr="2_diagram_app_workflow.png"/>
-          <p:cNvPicPr>
-            <a:picLocks noChangeAspect="1"/>
-          </p:cNvPicPr>
+              <a:t>Outcome: Research Paper and Deliverables</a:t>
+            </a:r>
+          </a:p>
+        </p:txBody>
+      </p:sp>
+      <p:sp>
+        <p:nvSpPr>
+          <p:cNvPr id="6" name="Slide Number Placeholder 5">
+            <a:extLst>
+              <a:ext uri="{FF2B5EF4-FFF2-40B4-BE49-F238E27FC236}">
+                <a16:creationId xmlns:a16="http://schemas.microsoft.com/office/drawing/2014/main" id="{B0CEE340-DD05-ABF3-E2C1-1FCA7E601094}"/>
+              </a:ext>
+            </a:extLst>
+          </p:cNvPr>
+          <p:cNvSpPr>
+            <a:spLocks noGrp="1"/>
+          </p:cNvSpPr>
+          <p:nvPr>
+            <p:ph type="sldNum" sz="quarter" idx="12"/>
+          </p:nvPr>
+        </p:nvSpPr>
+        <p:spPr/>
+        <p:txBody>
+          <a:bodyPr/>
+          <a:lstStyle/>
+          <a:p>
+            <a:fld id="{D0D3D9D9-2323-4B14-959B-DD5C508B8A7B}" type="slidenum">
+              <a:rPr lang="en-US" b="1" smtClean="0"/>
+              <a:pPr/>
+              <a:t>1</a:t>
+            </a:fld>
+            <a:endParaRPr lang="en-US" b="1" dirty="0"/>
+          </a:p>
+        </p:txBody>
+      </p:sp>
+      <p:sp>
+        <p:nvSpPr>
+          <p:cNvPr id="7" name="IP card"/>
+          <p:cNvSpPr/>
           <p:nvPr/>
-        </p:nvPicPr>
-        <p:blipFill>
-          <a:blip r:embed="rId2"/>
-          <a:stretch>
-            <a:fillRect/>
-          </a:stretch>
-        </p:blipFill>
+        </p:nvSpPr>
         <p:spPr>
           <a:xfrm>
-            <a:off x="670767" y="1133856"/>
-            <a:ext cx="7802464" cy="5138928"/>
+            <a:off x="365760" y="1188720"/>
+            <a:ext cx="4480560" cy="4023360"/>
+          </a:xfrm>
+          <a:prstGeom prst="roundRect">
+            <a:avLst>
+              <a:gd name="adj" fmla="val 8000"/>
+            </a:avLst>
+          </a:prstGeom>
+          <a:solidFill>
+            <a:srgbClr val="FFFFFF"/>
+          </a:solidFill>
+          <a:ln w="12700">
+            <a:solidFill>
+              <a:srgbClr val="9DB7C9"/>
+            </a:solidFill>
+          </a:ln>
+          <a:effectLst/>
+        </p:spPr>
+        <p:style>
+          <a:lnRef idx="1">
+            <a:schemeClr val="accent1"/>
+          </a:lnRef>
+          <a:fillRef idx="3">
+            <a:schemeClr val="accent1"/>
+          </a:fillRef>
+          <a:effectRef idx="2">
+            <a:schemeClr val="accent1"/>
+          </a:effectRef>
+          <a:fontRef idx="minor">
+            <a:schemeClr val="lt1"/>
+          </a:fontRef>
+        </p:style>
+        <p:txBody>
+          <a:bodyPr rtlCol="0" anchor="ctr"/>
+          <a:lstStyle/>
+          <a:p>
+            <a:pPr algn="ctr"/>
+          </a:p>
+        </p:txBody>
+      </p:sp>
+      <p:sp>
+        <p:nvSpPr>
+          <p:cNvPr id="8" name="IP card head"/>
+          <p:cNvSpPr txBox="1"/>
+          <p:nvPr/>
+        </p:nvSpPr>
+        <p:spPr>
+          <a:xfrm>
+            <a:off x="594360" y="1353312"/>
+            <a:ext cx="4023360" cy="411480"/>
           </a:xfrm>
           <a:prstGeom prst="rect">
             <a:avLst/>
           </a:prstGeom>
+          <a:noFill/>
         </p:spPr>
-      </p:pic>
+        <p:txBody>
+          <a:bodyPr wrap="square" anchor="t" lIns="0" rIns="0" tIns="0" bIns="0">
+            <a:spAutoFit/>
+          </a:bodyPr>
+          <a:lstStyle/>
+          <a:p>
+            <a:pPr algn="l"/>
+            <a:r>
+              <a:rPr sz="1900" b="1">
+                <a:solidFill>
+                  <a:srgbClr val="1F3864"/>
+                </a:solidFill>
+                <a:latin typeface="Times New Roman"/>
+              </a:rPr>
+              <a:t>Research output</a:t>
+            </a:r>
+          </a:p>
+        </p:txBody>
+      </p:sp>
+      <p:sp>
+        <p:nvSpPr>
+          <p:cNvPr id="9" name="IP points"/>
+          <p:cNvSpPr txBox="1"/>
+          <p:nvPr/>
+        </p:nvSpPr>
+        <p:spPr>
+          <a:xfrm>
+            <a:off x="594360" y="1737360"/>
+            <a:ext cx="4023360" cy="3429000"/>
+          </a:xfrm>
+          <a:prstGeom prst="rect">
+            <a:avLst/>
+          </a:prstGeom>
+          <a:noFill/>
+        </p:spPr>
+        <p:txBody>
+          <a:bodyPr wrap="square" anchor="t" lIns="0" rIns="0" tIns="0" bIns="0">
+            <a:spAutoFit/>
+          </a:bodyPr>
+          <a:lstStyle/>
+          <a:p>
+            <a:pPr marL="228600" indent="-228600">
+              <a:spcAft>
+                <a:spcPts val="700"/>
+              </a:spcAft>
+              <a:buFont typeface="Arial"/>
+              <a:buChar char="•"/>
+            </a:pPr>
+            <a:r>
+              <a:rPr sz="1600" b="1">
+                <a:solidFill>
+                  <a:srgbClr val="1F3864"/>
+                </a:solidFill>
+                <a:latin typeface="Times New Roman"/>
+              </a:rPr>
+              <a:t>RefurbIQ paper draft in progress: all six results tables filled from computed outputs</a:t>
+            </a:r>
+          </a:p>
+          <a:p>
+            <a:pPr marL="228600" indent="-228600">
+              <a:spcAft>
+                <a:spcPts val="700"/>
+              </a:spcAft>
+              <a:buFont typeface="Arial"/>
+              <a:buChar char="•"/>
+            </a:pPr>
+            <a:r>
+              <a:rPr sz="1600" b="1">
+                <a:solidFill>
+                  <a:srgbClr val="1F3864"/>
+                </a:solidFill>
+                <a:latin typeface="Times New Roman"/>
+              </a:rPr>
+              <a:t>Planned venue: [XX]</a:t>
+            </a:r>
+          </a:p>
+          <a:p>
+            <a:pPr marL="228600" indent="-228600">
+              <a:spcAft>
+                <a:spcPts val="700"/>
+              </a:spcAft>
+              <a:buFont typeface="Arial"/>
+              <a:buChar char="•"/>
+            </a:pPr>
+            <a:r>
+              <a:rPr sz="1600" b="1">
+                <a:solidFill>
+                  <a:srgbClr val="1F3864"/>
+                </a:solidFill>
+                <a:latin typeface="Times New Roman"/>
+              </a:rPr>
+              <a:t>Every reported number is reproducible via the scripts in research/scripts/</a:t>
+            </a:r>
+          </a:p>
+          <a:p>
+            <a:pPr marL="228600" indent="-228600">
+              <a:spcAft>
+                <a:spcPts val="700"/>
+              </a:spcAft>
+              <a:buFont typeface="Arial"/>
+              <a:buChar char="•"/>
+            </a:pPr>
+            <a:r>
+              <a:rPr sz="1600" b="1">
+                <a:solidFill>
+                  <a:srgbClr val="1F3864"/>
+                </a:solidFill>
+                <a:latin typeface="Times New Roman"/>
+              </a:rPr>
+              <a:t>Dataset is labelled synthetic; real-review validation is the next step</a:t>
+            </a:r>
+          </a:p>
+        </p:txBody>
+      </p:sp>
+      <p:sp>
+        <p:nvSpPr>
+          <p:cNvPr id="10" name="Deliverables card"/>
+          <p:cNvSpPr/>
+          <p:nvPr/>
+        </p:nvSpPr>
+        <p:spPr>
+          <a:xfrm>
+            <a:off x="5029200" y="1188720"/>
+            <a:ext cx="3566160" cy="4023360"/>
+          </a:xfrm>
+          <a:prstGeom prst="roundRect">
+            <a:avLst>
+              <a:gd name="adj" fmla="val 8000"/>
+            </a:avLst>
+          </a:prstGeom>
+          <a:solidFill>
+            <a:srgbClr val="E4F3F1"/>
+          </a:solidFill>
+          <a:ln w="12700">
+            <a:solidFill>
+              <a:srgbClr val="9DB7C9"/>
+            </a:solidFill>
+          </a:ln>
+          <a:effectLst/>
+        </p:spPr>
+        <p:style>
+          <a:lnRef idx="1">
+            <a:schemeClr val="accent1"/>
+          </a:lnRef>
+          <a:fillRef idx="3">
+            <a:schemeClr val="accent1"/>
+          </a:fillRef>
+          <a:effectRef idx="2">
+            <a:schemeClr val="accent1"/>
+          </a:effectRef>
+          <a:fontRef idx="minor">
+            <a:schemeClr val="lt1"/>
+          </a:fontRef>
+        </p:style>
+        <p:txBody>
+          <a:bodyPr rtlCol="0" anchor="ctr"/>
+          <a:lstStyle/>
+          <a:p>
+            <a:pPr algn="ctr"/>
+          </a:p>
+        </p:txBody>
+      </p:sp>
+      <p:sp>
+        <p:nvSpPr>
+          <p:cNvPr id="11" name="Deliverables card head"/>
+          <p:cNvSpPr txBox="1"/>
+          <p:nvPr/>
+        </p:nvSpPr>
+        <p:spPr>
+          <a:xfrm>
+            <a:off x="5257800" y="1353312"/>
+            <a:ext cx="3108960" cy="411480"/>
+          </a:xfrm>
+          <a:prstGeom prst="rect">
+            <a:avLst/>
+          </a:prstGeom>
+          <a:noFill/>
+        </p:spPr>
+        <p:txBody>
+          <a:bodyPr wrap="square" anchor="t" lIns="0" rIns="0" tIns="0" bIns="0">
+            <a:spAutoFit/>
+          </a:bodyPr>
+          <a:lstStyle/>
+          <a:p>
+            <a:pPr algn="l"/>
+            <a:r>
+              <a:rPr sz="1900" b="1">
+                <a:solidFill>
+                  <a:srgbClr val="1F6F78"/>
+                </a:solidFill>
+                <a:latin typeface="Times New Roman"/>
+              </a:rPr>
+              <a:t>Deliverables</a:t>
+            </a:r>
+          </a:p>
+        </p:txBody>
+      </p:sp>
+      <p:sp>
+        <p:nvSpPr>
+          <p:cNvPr id="12" name="Deliverables points"/>
+          <p:cNvSpPr txBox="1"/>
+          <p:nvPr/>
+        </p:nvSpPr>
+        <p:spPr>
+          <a:xfrm>
+            <a:off x="5257800" y="1737360"/>
+            <a:ext cx="3108960" cy="3429000"/>
+          </a:xfrm>
+          <a:prstGeom prst="rect">
+            <a:avLst/>
+          </a:prstGeom>
+          <a:noFill/>
+        </p:spPr>
+        <p:txBody>
+          <a:bodyPr wrap="square" anchor="t" lIns="0" rIns="0" tIns="0" bIns="0">
+            <a:spAutoFit/>
+          </a:bodyPr>
+          <a:lstStyle/>
+          <a:p>
+            <a:pPr marL="228600" indent="-228600">
+              <a:spcAft>
+                <a:spcPts val="900"/>
+              </a:spcAft>
+              <a:buFont typeface="Arial"/>
+              <a:buChar char="•"/>
+            </a:pPr>
+            <a:r>
+              <a:rPr sz="1700">
+                <a:solidFill>
+                  <a:srgbClr val="26323F"/>
+                </a:solidFill>
+                <a:latin typeface="Times New Roman"/>
+              </a:rPr>
+              <a:t>Labelled dataset: 2,000 reviews, 3,548 aspect annotations</a:t>
+            </a:r>
+          </a:p>
+          <a:p>
+            <a:pPr marL="228600" indent="-228600">
+              <a:spcAft>
+                <a:spcPts val="900"/>
+              </a:spcAft>
+              <a:buFont typeface="Arial"/>
+              <a:buChar char="•"/>
+            </a:pPr>
+            <a:r>
+              <a:rPr sz="1700">
+                <a:solidFill>
+                  <a:srgbClr val="26323F"/>
+                </a:solidFill>
+                <a:latin typeface="Times New Roman"/>
+              </a:rPr>
+              <a:t>Reproducible Python code (pushed to GitHub)</a:t>
+            </a:r>
+          </a:p>
+          <a:p>
+            <a:pPr marL="228600" indent="-228600">
+              <a:spcAft>
+                <a:spcPts val="900"/>
+              </a:spcAft>
+              <a:buFont typeface="Arial"/>
+              <a:buChar char="•"/>
+            </a:pPr>
+            <a:r>
+              <a:rPr sz="1700">
+                <a:solidFill>
+                  <a:srgbClr val="26323F"/>
+                </a:solidFill>
+                <a:latin typeface="Times New Roman"/>
+              </a:rPr>
+              <a:t>Nine-aspect taxonomy for refurbished electronics</a:t>
+            </a:r>
+          </a:p>
+          <a:p>
+            <a:pPr marL="228600" indent="-228600">
+              <a:spcAft>
+                <a:spcPts val="900"/>
+              </a:spcAft>
+              <a:buFont typeface="Arial"/>
+              <a:buChar char="•"/>
+            </a:pPr>
+            <a:r>
+              <a:rPr sz="1700">
+                <a:solidFill>
+                  <a:srgbClr val="26323F"/>
+                </a:solidFill>
+                <a:latin typeface="Times New Roman"/>
+              </a:rPr>
+              <a:t>Four-model comparison on a common leak-free protocol</a:t>
+            </a:r>
+          </a:p>
+        </p:txBody>
+      </p:sp>
+      <p:sp>
+        <p:nvSpPr>
+          <p:cNvPr id="13" name="Draft title strip"/>
+          <p:cNvSpPr/>
+          <p:nvPr/>
+        </p:nvSpPr>
+        <p:spPr>
+          <a:xfrm>
+            <a:off x="365760" y="5394960"/>
+            <a:ext cx="8229600" cy="868680"/>
+          </a:xfrm>
+          <a:prstGeom prst="roundRect">
+            <a:avLst>
+              <a:gd name="adj" fmla="val 8000"/>
+            </a:avLst>
+          </a:prstGeom>
+          <a:solidFill>
+            <a:srgbClr val="E6EFF8"/>
+          </a:solidFill>
+          <a:ln w="12700">
+            <a:solidFill>
+              <a:srgbClr val="9DB7C9"/>
+            </a:solidFill>
+          </a:ln>
+          <a:effectLst/>
+        </p:spPr>
+        <p:style>
+          <a:lnRef idx="1">
+            <a:schemeClr val="accent1"/>
+          </a:lnRef>
+          <a:fillRef idx="3">
+            <a:schemeClr val="accent1"/>
+          </a:fillRef>
+          <a:effectRef idx="2">
+            <a:schemeClr val="accent1"/>
+          </a:effectRef>
+          <a:fontRef idx="minor">
+            <a:schemeClr val="lt1"/>
+          </a:fontRef>
+        </p:style>
+        <p:txBody>
+          <a:bodyPr rtlCol="0" anchor="ctr"/>
+          <a:lstStyle/>
+          <a:p>
+            <a:pPr algn="ctr"/>
+          </a:p>
+        </p:txBody>
+      </p:sp>
+      <p:sp>
+        <p:nvSpPr>
+          <p:cNvPr id="14" name="Draft title text"/>
+          <p:cNvSpPr txBox="1"/>
+          <p:nvPr/>
+        </p:nvSpPr>
+        <p:spPr>
+          <a:xfrm>
+            <a:off x="594360" y="5440680"/>
+            <a:ext cx="7772400" cy="777240"/>
+          </a:xfrm>
+          <a:prstGeom prst="rect">
+            <a:avLst/>
+          </a:prstGeom>
+          <a:noFill/>
+        </p:spPr>
+        <p:txBody>
+          <a:bodyPr wrap="square" anchor="ctr" lIns="0" rIns="0" tIns="0" bIns="0">
+            <a:spAutoFit/>
+          </a:bodyPr>
+          <a:lstStyle/>
+          <a:p>
+            <a:pPr algn="l"/>
+            <a:r>
+              <a:rPr sz="1400" b="1">
+                <a:solidFill>
+                  <a:srgbClr val="1F3864"/>
+                </a:solidFill>
+                <a:latin typeface="Times New Roman"/>
+              </a:rPr>
+              <a:t>Paper title: RefurbIQ: Aspect-Based Sentiment Analysis of Refurbished Electronics Across Indian Marketplaces - draft in progress.</a:t>
+            </a:r>
+          </a:p>
+        </p:txBody>
+      </p:sp>
     </p:spTree>
   </p:cSld>
   <p:clrMapOvr>
@@ -18197,6 +17187,15 @@
 <file path=ppt/slides/slide21.xml><?xml version="1.0" encoding="utf-8"?>
 <p:sld xmlns:a="http://schemas.openxmlformats.org/drawingml/2006/main" xmlns:p="http://schemas.openxmlformats.org/presentationml/2006/main" xmlns:r="http://schemas.openxmlformats.org/officeDocument/2006/relationships">
   <p:cSld>
+    <p:bg>
+      <p:bgPr>
+        <a:blipFill>
+          <a:blip r:embed="rId2"/>
+          <a:tile tx="0" ty="0" sx="100000" sy="100000" flip="none" algn="tl"/>
+        </a:blipFill>
+        <a:effectLst/>
+      </p:bgPr>
+    </p:bg>
     <p:spTree>
       <p:nvGrpSpPr>
         <p:cNvPr id="1" name=""/>
@@ -18214,9 +17213,25 @@
             <p:ph type="title"/>
           </p:nvPr>
         </p:nvSpPr>
-        <p:spPr/>
-        <p:txBody>
-          <a:bodyPr/>
+        <p:spPr>
+          <a:xfrm>
+            <a:off x="446314" y="122238"/>
+            <a:ext cx="8229600" cy="868362"/>
+          </a:xfrm>
+          <a:prstGeom prst="roundRect">
+            <a:avLst/>
+          </a:prstGeom>
+          <a:solidFill>
+            <a:srgbClr val="E6EFF4"/>
+          </a:solidFill>
+          <a:ln w="19050">
+            <a:solidFill>
+              <a:srgbClr val="FFFFFF"/>
+            </a:solidFill>
+          </a:ln>
+        </p:spPr>
+        <p:txBody>
+          <a:bodyPr anchor="ctr"/>
           <a:lstStyle/>
           <a:p>
             <a:pPr algn="ctr"/>
@@ -18227,35 +17242,1020 @@
                 </a:solidFill>
                 <a:latin typeface="Times New Roman"/>
               </a:rPr>
-              <a:t>Recommendation Engine</a:t>
-            </a:r>
-          </a:p>
-        </p:txBody>
-      </p:sp>
-      <p:pic>
-        <p:nvPicPr>
-          <p:cNvPr id="3" name="Picture 2" descr="4_diagram_recommendation.png"/>
-          <p:cNvPicPr>
-            <a:picLocks noChangeAspect="1"/>
-          </p:cNvPicPr>
+              <a:t>References</a:t>
+            </a:r>
+          </a:p>
+        </p:txBody>
+      </p:sp>
+      <p:sp>
+        <p:nvSpPr>
+          <p:cNvPr id="6" name="Slide Number Placeholder 5">
+            <a:extLst>
+              <a:ext uri="{FF2B5EF4-FFF2-40B4-BE49-F238E27FC236}">
+                <a16:creationId xmlns:a16="http://schemas.microsoft.com/office/drawing/2014/main" id="{B0CEE340-DD05-ABF3-E2C1-1FCA7E601094}"/>
+              </a:ext>
+            </a:extLst>
+          </p:cNvPr>
+          <p:cNvSpPr>
+            <a:spLocks noGrp="1"/>
+          </p:cNvSpPr>
+          <p:nvPr>
+            <p:ph type="sldNum" sz="quarter" idx="12"/>
+          </p:nvPr>
+        </p:nvSpPr>
+        <p:spPr/>
+        <p:txBody>
+          <a:bodyPr/>
+          <a:lstStyle/>
+          <a:p>
+            <a:fld id="{D0D3D9D9-2323-4B14-959B-DD5C508B8A7B}" type="slidenum">
+              <a:rPr lang="en-US" b="1" smtClean="0"/>
+              <a:pPr/>
+              <a:t>1</a:t>
+            </a:fld>
+            <a:endParaRPr lang="en-US" b="1" dirty="0"/>
+          </a:p>
+        </p:txBody>
+      </p:sp>
+      <p:sp>
+        <p:nvSpPr>
+          <p:cNvPr id="7" name="Reference card 1"/>
+          <p:cNvSpPr/>
           <p:nvPr/>
-        </p:nvPicPr>
-        <p:blipFill>
-          <a:blip r:embed="rId2"/>
-          <a:stretch>
-            <a:fillRect/>
-          </a:stretch>
-        </p:blipFill>
+        </p:nvSpPr>
         <p:spPr>
           <a:xfrm>
-            <a:off x="492107" y="1133856"/>
-            <a:ext cx="8159784" cy="5138928"/>
+            <a:off x="365760" y="1188720"/>
+            <a:ext cx="8229600" cy="548640"/>
+          </a:xfrm>
+          <a:prstGeom prst="roundRect">
+            <a:avLst>
+              <a:gd name="adj" fmla="val 8000"/>
+            </a:avLst>
+          </a:prstGeom>
+          <a:solidFill>
+            <a:srgbClr val="FFFFFF"/>
+          </a:solidFill>
+          <a:ln w="12700">
+            <a:solidFill>
+              <a:srgbClr val="9DB7C9"/>
+            </a:solidFill>
+          </a:ln>
+          <a:effectLst/>
+        </p:spPr>
+        <p:style>
+          <a:lnRef idx="1">
+            <a:schemeClr val="accent1"/>
+          </a:lnRef>
+          <a:fillRef idx="3">
+            <a:schemeClr val="accent1"/>
+          </a:fillRef>
+          <a:effectRef idx="2">
+            <a:schemeClr val="accent1"/>
+          </a:effectRef>
+          <a:fontRef idx="minor">
+            <a:schemeClr val="lt1"/>
+          </a:fontRef>
+        </p:style>
+        <p:txBody>
+          <a:bodyPr rtlCol="0" anchor="ctr"/>
+          <a:lstStyle/>
+          <a:p>
+            <a:pPr algn="ctr"/>
+          </a:p>
+        </p:txBody>
+      </p:sp>
+      <p:sp>
+        <p:nvSpPr>
+          <p:cNvPr id="8" name="Reference id 1"/>
+          <p:cNvSpPr txBox="1"/>
+          <p:nvPr/>
+        </p:nvSpPr>
+        <p:spPr>
+          <a:xfrm>
+            <a:off x="502920" y="1216152"/>
+            <a:ext cx="685800" cy="493776"/>
           </a:xfrm>
           <a:prstGeom prst="rect">
             <a:avLst/>
           </a:prstGeom>
+          <a:noFill/>
         </p:spPr>
-      </p:pic>
+        <p:txBody>
+          <a:bodyPr wrap="square" anchor="ctr" lIns="0" rIns="0" tIns="0" bIns="0">
+            <a:spAutoFit/>
+          </a:bodyPr>
+          <a:lstStyle/>
+          <a:p>
+            <a:pPr algn="l"/>
+            <a:r>
+              <a:rPr sz="1400" b="1">
+                <a:solidFill>
+                  <a:srgbClr val="1F6F78"/>
+                </a:solidFill>
+                <a:latin typeface="Times New Roman"/>
+              </a:rPr>
+              <a:t>[1]</a:t>
+            </a:r>
+          </a:p>
+        </p:txBody>
+      </p:sp>
+      <p:sp>
+        <p:nvSpPr>
+          <p:cNvPr id="9" name="Reference text 1"/>
+          <p:cNvSpPr txBox="1"/>
+          <p:nvPr/>
+        </p:nvSpPr>
+        <p:spPr>
+          <a:xfrm>
+            <a:off x="1234440" y="1216152"/>
+            <a:ext cx="7269480" cy="493776"/>
+          </a:xfrm>
+          <a:prstGeom prst="rect">
+            <a:avLst/>
+          </a:prstGeom>
+          <a:noFill/>
+        </p:spPr>
+        <p:txBody>
+          <a:bodyPr wrap="square" anchor="ctr" lIns="0" rIns="0" tIns="0" bIns="0">
+            <a:spAutoFit/>
+          </a:bodyPr>
+          <a:lstStyle/>
+          <a:p>
+            <a:pPr algn="l"/>
+            <a:r>
+              <a:rPr sz="1300">
+                <a:solidFill>
+                  <a:srgbClr val="26323F"/>
+                </a:solidFill>
+                <a:latin typeface="Times New Roman"/>
+              </a:rPr>
+              <a:t>A. Chevalier and M. Mayzlin, “The effect of word of mouth on sales: Online book reviews,” J. Marketing Research, vol. 43, no. 3, pp. 345–354, 2006.</a:t>
+            </a:r>
+          </a:p>
+        </p:txBody>
+      </p:sp>
+      <p:sp>
+        <p:nvSpPr>
+          <p:cNvPr id="10" name="Reference card 2"/>
+          <p:cNvSpPr/>
+          <p:nvPr/>
+        </p:nvSpPr>
+        <p:spPr>
+          <a:xfrm>
+            <a:off x="365760" y="1792224"/>
+            <a:ext cx="8229600" cy="731520"/>
+          </a:xfrm>
+          <a:prstGeom prst="roundRect">
+            <a:avLst>
+              <a:gd name="adj" fmla="val 8000"/>
+            </a:avLst>
+          </a:prstGeom>
+          <a:solidFill>
+            <a:srgbClr val="FFFFFF"/>
+          </a:solidFill>
+          <a:ln w="12700">
+            <a:solidFill>
+              <a:srgbClr val="9DB7C9"/>
+            </a:solidFill>
+          </a:ln>
+          <a:effectLst/>
+        </p:spPr>
+        <p:style>
+          <a:lnRef idx="1">
+            <a:schemeClr val="accent1"/>
+          </a:lnRef>
+          <a:fillRef idx="3">
+            <a:schemeClr val="accent1"/>
+          </a:fillRef>
+          <a:effectRef idx="2">
+            <a:schemeClr val="accent1"/>
+          </a:effectRef>
+          <a:fontRef idx="minor">
+            <a:schemeClr val="lt1"/>
+          </a:fontRef>
+        </p:style>
+        <p:txBody>
+          <a:bodyPr rtlCol="0" anchor="ctr"/>
+          <a:lstStyle/>
+          <a:p>
+            <a:pPr algn="ctr"/>
+          </a:p>
+        </p:txBody>
+      </p:sp>
+      <p:sp>
+        <p:nvSpPr>
+          <p:cNvPr id="11" name="Reference id 2"/>
+          <p:cNvSpPr txBox="1"/>
+          <p:nvPr/>
+        </p:nvSpPr>
+        <p:spPr>
+          <a:xfrm>
+            <a:off x="502920" y="1819656"/>
+            <a:ext cx="685800" cy="676656"/>
+          </a:xfrm>
+          <a:prstGeom prst="rect">
+            <a:avLst/>
+          </a:prstGeom>
+          <a:noFill/>
+        </p:spPr>
+        <p:txBody>
+          <a:bodyPr wrap="square" anchor="ctr" lIns="0" rIns="0" tIns="0" bIns="0">
+            <a:spAutoFit/>
+          </a:bodyPr>
+          <a:lstStyle/>
+          <a:p>
+            <a:pPr algn="l"/>
+            <a:r>
+              <a:rPr sz="1400" b="1">
+                <a:solidFill>
+                  <a:srgbClr val="1F6F78"/>
+                </a:solidFill>
+                <a:latin typeface="Times New Roman"/>
+              </a:rPr>
+              <a:t>[2]</a:t>
+            </a:r>
+          </a:p>
+        </p:txBody>
+      </p:sp>
+      <p:sp>
+        <p:nvSpPr>
+          <p:cNvPr id="12" name="Reference text 2"/>
+          <p:cNvSpPr txBox="1"/>
+          <p:nvPr/>
+        </p:nvSpPr>
+        <p:spPr>
+          <a:xfrm>
+            <a:off x="1234440" y="1819656"/>
+            <a:ext cx="7269480" cy="676656"/>
+          </a:xfrm>
+          <a:prstGeom prst="rect">
+            <a:avLst/>
+          </a:prstGeom>
+          <a:noFill/>
+        </p:spPr>
+        <p:txBody>
+          <a:bodyPr wrap="square" anchor="ctr" lIns="0" rIns="0" tIns="0" bIns="0">
+            <a:spAutoFit/>
+          </a:bodyPr>
+          <a:lstStyle/>
+          <a:p>
+            <a:pPr algn="l"/>
+            <a:r>
+              <a:rPr sz="1300">
+                <a:solidFill>
+                  <a:srgbClr val="26323F"/>
+                </a:solidFill>
+                <a:latin typeface="Times New Roman"/>
+              </a:rPr>
+              <a:t>B. Liu, Sentiment Analysis and Opinion Mining. Morgan &amp; Claypool, 2012.</a:t>
+            </a:r>
+          </a:p>
+        </p:txBody>
+      </p:sp>
+      <p:sp>
+        <p:nvSpPr>
+          <p:cNvPr id="13" name="Reference card 3"/>
+          <p:cNvSpPr/>
+          <p:nvPr/>
+        </p:nvSpPr>
+        <p:spPr>
+          <a:xfrm>
+            <a:off x="365760" y="2578608"/>
+            <a:ext cx="8229600" cy="548640"/>
+          </a:xfrm>
+          <a:prstGeom prst="roundRect">
+            <a:avLst>
+              <a:gd name="adj" fmla="val 8000"/>
+            </a:avLst>
+          </a:prstGeom>
+          <a:solidFill>
+            <a:srgbClr val="FFFFFF"/>
+          </a:solidFill>
+          <a:ln w="12700">
+            <a:solidFill>
+              <a:srgbClr val="9DB7C9"/>
+            </a:solidFill>
+          </a:ln>
+          <a:effectLst/>
+        </p:spPr>
+        <p:style>
+          <a:lnRef idx="1">
+            <a:schemeClr val="accent1"/>
+          </a:lnRef>
+          <a:fillRef idx="3">
+            <a:schemeClr val="accent1"/>
+          </a:fillRef>
+          <a:effectRef idx="2">
+            <a:schemeClr val="accent1"/>
+          </a:effectRef>
+          <a:fontRef idx="minor">
+            <a:schemeClr val="lt1"/>
+          </a:fontRef>
+        </p:style>
+        <p:txBody>
+          <a:bodyPr rtlCol="0" anchor="ctr"/>
+          <a:lstStyle/>
+          <a:p>
+            <a:pPr algn="ctr"/>
+          </a:p>
+        </p:txBody>
+      </p:sp>
+      <p:sp>
+        <p:nvSpPr>
+          <p:cNvPr id="14" name="Reference id 3"/>
+          <p:cNvSpPr txBox="1"/>
+          <p:nvPr/>
+        </p:nvSpPr>
+        <p:spPr>
+          <a:xfrm>
+            <a:off x="502920" y="2606040"/>
+            <a:ext cx="685800" cy="493776"/>
+          </a:xfrm>
+          <a:prstGeom prst="rect">
+            <a:avLst/>
+          </a:prstGeom>
+          <a:noFill/>
+        </p:spPr>
+        <p:txBody>
+          <a:bodyPr wrap="square" anchor="ctr" lIns="0" rIns="0" tIns="0" bIns="0">
+            <a:spAutoFit/>
+          </a:bodyPr>
+          <a:lstStyle/>
+          <a:p>
+            <a:pPr algn="l"/>
+            <a:r>
+              <a:rPr sz="1400" b="1">
+                <a:solidFill>
+                  <a:srgbClr val="1F6F78"/>
+                </a:solidFill>
+                <a:latin typeface="Times New Roman"/>
+              </a:rPr>
+              <a:t>[3]</a:t>
+            </a:r>
+          </a:p>
+        </p:txBody>
+      </p:sp>
+      <p:sp>
+        <p:nvSpPr>
+          <p:cNvPr id="15" name="Reference text 3"/>
+          <p:cNvSpPr txBox="1"/>
+          <p:nvPr/>
+        </p:nvSpPr>
+        <p:spPr>
+          <a:xfrm>
+            <a:off x="1234440" y="2606040"/>
+            <a:ext cx="7269480" cy="493776"/>
+          </a:xfrm>
+          <a:prstGeom prst="rect">
+            <a:avLst/>
+          </a:prstGeom>
+          <a:noFill/>
+        </p:spPr>
+        <p:txBody>
+          <a:bodyPr wrap="square" anchor="ctr" lIns="0" rIns="0" tIns="0" bIns="0">
+            <a:spAutoFit/>
+          </a:bodyPr>
+          <a:lstStyle/>
+          <a:p>
+            <a:pPr algn="l"/>
+            <a:r>
+              <a:rPr sz="1300">
+                <a:solidFill>
+                  <a:srgbClr val="26323F"/>
+                </a:solidFill>
+                <a:latin typeface="Times New Roman"/>
+              </a:rPr>
+              <a:t>B. Pang and L. Lee, “Opinion mining and sentiment analysis,” Foundations and Trends in Information Retrieval, vol. 2, no. 1–2, pp. 1–135, 2008.</a:t>
+            </a:r>
+          </a:p>
+        </p:txBody>
+      </p:sp>
+      <p:sp>
+        <p:nvSpPr>
+          <p:cNvPr id="16" name="Reference card 4"/>
+          <p:cNvSpPr/>
+          <p:nvPr/>
+        </p:nvSpPr>
+        <p:spPr>
+          <a:xfrm>
+            <a:off x="365760" y="3182112"/>
+            <a:ext cx="8229600" cy="457200"/>
+          </a:xfrm>
+          <a:prstGeom prst="roundRect">
+            <a:avLst>
+              <a:gd name="adj" fmla="val 8000"/>
+            </a:avLst>
+          </a:prstGeom>
+          <a:solidFill>
+            <a:srgbClr val="FFFFFF"/>
+          </a:solidFill>
+          <a:ln w="12700">
+            <a:solidFill>
+              <a:srgbClr val="9DB7C9"/>
+            </a:solidFill>
+          </a:ln>
+          <a:effectLst/>
+        </p:spPr>
+        <p:style>
+          <a:lnRef idx="1">
+            <a:schemeClr val="accent1"/>
+          </a:lnRef>
+          <a:fillRef idx="3">
+            <a:schemeClr val="accent1"/>
+          </a:fillRef>
+          <a:effectRef idx="2">
+            <a:schemeClr val="accent1"/>
+          </a:effectRef>
+          <a:fontRef idx="minor">
+            <a:schemeClr val="lt1"/>
+          </a:fontRef>
+        </p:style>
+        <p:txBody>
+          <a:bodyPr rtlCol="0" anchor="ctr"/>
+          <a:lstStyle/>
+          <a:p>
+            <a:pPr algn="ctr"/>
+          </a:p>
+        </p:txBody>
+      </p:sp>
+      <p:sp>
+        <p:nvSpPr>
+          <p:cNvPr id="17" name="Reference id 4"/>
+          <p:cNvSpPr txBox="1"/>
+          <p:nvPr/>
+        </p:nvSpPr>
+        <p:spPr>
+          <a:xfrm>
+            <a:off x="502920" y="3209544"/>
+            <a:ext cx="685800" cy="402336"/>
+          </a:xfrm>
+          <a:prstGeom prst="rect">
+            <a:avLst/>
+          </a:prstGeom>
+          <a:noFill/>
+        </p:spPr>
+        <p:txBody>
+          <a:bodyPr wrap="square" anchor="ctr" lIns="0" rIns="0" tIns="0" bIns="0">
+            <a:spAutoFit/>
+          </a:bodyPr>
+          <a:lstStyle/>
+          <a:p>
+            <a:pPr algn="l"/>
+            <a:r>
+              <a:rPr sz="1400" b="1">
+                <a:solidFill>
+                  <a:srgbClr val="1F6F78"/>
+                </a:solidFill>
+                <a:latin typeface="Times New Roman"/>
+              </a:rPr>
+              <a:t>[4]</a:t>
+            </a:r>
+          </a:p>
+        </p:txBody>
+      </p:sp>
+      <p:sp>
+        <p:nvSpPr>
+          <p:cNvPr id="18" name="Reference text 4"/>
+          <p:cNvSpPr txBox="1"/>
+          <p:nvPr/>
+        </p:nvSpPr>
+        <p:spPr>
+          <a:xfrm>
+            <a:off x="1234440" y="3209544"/>
+            <a:ext cx="7269480" cy="402336"/>
+          </a:xfrm>
+          <a:prstGeom prst="rect">
+            <a:avLst/>
+          </a:prstGeom>
+          <a:noFill/>
+        </p:spPr>
+        <p:txBody>
+          <a:bodyPr wrap="square" anchor="ctr" lIns="0" rIns="0" tIns="0" bIns="0">
+            <a:spAutoFit/>
+          </a:bodyPr>
+          <a:lstStyle/>
+          <a:p>
+            <a:pPr algn="l"/>
+            <a:r>
+              <a:rPr sz="1300">
+                <a:solidFill>
+                  <a:srgbClr val="26323F"/>
+                </a:solidFill>
+                <a:latin typeface="Times New Roman"/>
+              </a:rPr>
+              <a:t>M. Hu and B. Liu, “Mining and summarizing customer reviews,” in Proc. KDD, 2004, pp. 168–177.</a:t>
+            </a:r>
+          </a:p>
+        </p:txBody>
+      </p:sp>
+      <p:sp>
+        <p:nvSpPr>
+          <p:cNvPr id="19" name="Reference card 5"/>
+          <p:cNvSpPr/>
+          <p:nvPr/>
+        </p:nvSpPr>
+        <p:spPr>
+          <a:xfrm>
+            <a:off x="365760" y="3694176"/>
+            <a:ext cx="8229600" cy="594360"/>
+          </a:xfrm>
+          <a:prstGeom prst="roundRect">
+            <a:avLst>
+              <a:gd name="adj" fmla="val 8000"/>
+            </a:avLst>
+          </a:prstGeom>
+          <a:solidFill>
+            <a:srgbClr val="FFFFFF"/>
+          </a:solidFill>
+          <a:ln w="12700">
+            <a:solidFill>
+              <a:srgbClr val="9DB7C9"/>
+            </a:solidFill>
+          </a:ln>
+          <a:effectLst/>
+        </p:spPr>
+        <p:style>
+          <a:lnRef idx="1">
+            <a:schemeClr val="accent1"/>
+          </a:lnRef>
+          <a:fillRef idx="3">
+            <a:schemeClr val="accent1"/>
+          </a:fillRef>
+          <a:effectRef idx="2">
+            <a:schemeClr val="accent1"/>
+          </a:effectRef>
+          <a:fontRef idx="minor">
+            <a:schemeClr val="lt1"/>
+          </a:fontRef>
+        </p:style>
+        <p:txBody>
+          <a:bodyPr rtlCol="0" anchor="ctr"/>
+          <a:lstStyle/>
+          <a:p>
+            <a:pPr algn="ctr"/>
+          </a:p>
+        </p:txBody>
+      </p:sp>
+      <p:sp>
+        <p:nvSpPr>
+          <p:cNvPr id="20" name="Reference id 5"/>
+          <p:cNvSpPr txBox="1"/>
+          <p:nvPr/>
+        </p:nvSpPr>
+        <p:spPr>
+          <a:xfrm>
+            <a:off x="502920" y="3721608"/>
+            <a:ext cx="685800" cy="539496"/>
+          </a:xfrm>
+          <a:prstGeom prst="rect">
+            <a:avLst/>
+          </a:prstGeom>
+          <a:noFill/>
+        </p:spPr>
+        <p:txBody>
+          <a:bodyPr wrap="square" anchor="ctr" lIns="0" rIns="0" tIns="0" bIns="0">
+            <a:spAutoFit/>
+          </a:bodyPr>
+          <a:lstStyle/>
+          <a:p>
+            <a:pPr algn="l"/>
+            <a:r>
+              <a:rPr sz="1400" b="1">
+                <a:solidFill>
+                  <a:srgbClr val="1F6F78"/>
+                </a:solidFill>
+                <a:latin typeface="Times New Roman"/>
+              </a:rPr>
+              <a:t>[5]</a:t>
+            </a:r>
+          </a:p>
+        </p:txBody>
+      </p:sp>
+      <p:sp>
+        <p:nvSpPr>
+          <p:cNvPr id="21" name="Reference text 5"/>
+          <p:cNvSpPr txBox="1"/>
+          <p:nvPr/>
+        </p:nvSpPr>
+        <p:spPr>
+          <a:xfrm>
+            <a:off x="1234440" y="3721608"/>
+            <a:ext cx="7269480" cy="539496"/>
+          </a:xfrm>
+          <a:prstGeom prst="rect">
+            <a:avLst/>
+          </a:prstGeom>
+          <a:noFill/>
+        </p:spPr>
+        <p:txBody>
+          <a:bodyPr wrap="square" anchor="ctr" lIns="0" rIns="0" tIns="0" bIns="0">
+            <a:spAutoFit/>
+          </a:bodyPr>
+          <a:lstStyle/>
+          <a:p>
+            <a:pPr algn="l"/>
+            <a:r>
+              <a:rPr sz="1300">
+                <a:solidFill>
+                  <a:srgbClr val="26323F"/>
+                </a:solidFill>
+                <a:latin typeface="Times New Roman"/>
+              </a:rPr>
+              <a:t>M. Pontiki et al., “SemEval-2014 Task 4: Aspect based sentiment analysis,” in Proc. SemEval, 2014, pp. 27–35.</a:t>
+            </a:r>
+          </a:p>
+        </p:txBody>
+      </p:sp>
+      <p:sp>
+        <p:nvSpPr>
+          <p:cNvPr id="22" name="Reference card 6"/>
+          <p:cNvSpPr/>
+          <p:nvPr/>
+        </p:nvSpPr>
+        <p:spPr>
+          <a:xfrm>
+            <a:off x="365760" y="4343400"/>
+            <a:ext cx="8229600" cy="548640"/>
+          </a:xfrm>
+          <a:prstGeom prst="roundRect">
+            <a:avLst>
+              <a:gd name="adj" fmla="val 8000"/>
+            </a:avLst>
+          </a:prstGeom>
+          <a:solidFill>
+            <a:srgbClr val="FFFFFF"/>
+          </a:solidFill>
+          <a:ln w="12700">
+            <a:solidFill>
+              <a:srgbClr val="9DB7C9"/>
+            </a:solidFill>
+          </a:ln>
+          <a:effectLst/>
+        </p:spPr>
+        <p:style>
+          <a:lnRef idx="1">
+            <a:schemeClr val="accent1"/>
+          </a:lnRef>
+          <a:fillRef idx="3">
+            <a:schemeClr val="accent1"/>
+          </a:fillRef>
+          <a:effectRef idx="2">
+            <a:schemeClr val="accent1"/>
+          </a:effectRef>
+          <a:fontRef idx="minor">
+            <a:schemeClr val="lt1"/>
+          </a:fontRef>
+        </p:style>
+        <p:txBody>
+          <a:bodyPr rtlCol="0" anchor="ctr"/>
+          <a:lstStyle/>
+          <a:p>
+            <a:pPr algn="ctr"/>
+          </a:p>
+        </p:txBody>
+      </p:sp>
+      <p:sp>
+        <p:nvSpPr>
+          <p:cNvPr id="23" name="Reference id 6"/>
+          <p:cNvSpPr txBox="1"/>
+          <p:nvPr/>
+        </p:nvSpPr>
+        <p:spPr>
+          <a:xfrm>
+            <a:off x="502920" y="4370832"/>
+            <a:ext cx="685800" cy="493776"/>
+          </a:xfrm>
+          <a:prstGeom prst="rect">
+            <a:avLst/>
+          </a:prstGeom>
+          <a:noFill/>
+        </p:spPr>
+        <p:txBody>
+          <a:bodyPr wrap="square" anchor="ctr" lIns="0" rIns="0" tIns="0" bIns="0">
+            <a:spAutoFit/>
+          </a:bodyPr>
+          <a:lstStyle/>
+          <a:p>
+            <a:pPr algn="l"/>
+            <a:r>
+              <a:rPr sz="1400" b="1">
+                <a:solidFill>
+                  <a:srgbClr val="1F6F78"/>
+                </a:solidFill>
+                <a:latin typeface="Times New Roman"/>
+              </a:rPr>
+              <a:t>[6]</a:t>
+            </a:r>
+          </a:p>
+        </p:txBody>
+      </p:sp>
+      <p:sp>
+        <p:nvSpPr>
+          <p:cNvPr id="24" name="Reference text 6"/>
+          <p:cNvSpPr txBox="1"/>
+          <p:nvPr/>
+        </p:nvSpPr>
+        <p:spPr>
+          <a:xfrm>
+            <a:off x="1234440" y="4370832"/>
+            <a:ext cx="7269480" cy="493776"/>
+          </a:xfrm>
+          <a:prstGeom prst="rect">
+            <a:avLst/>
+          </a:prstGeom>
+          <a:noFill/>
+        </p:spPr>
+        <p:txBody>
+          <a:bodyPr wrap="square" anchor="ctr" lIns="0" rIns="0" tIns="0" bIns="0">
+            <a:spAutoFit/>
+          </a:bodyPr>
+          <a:lstStyle/>
+          <a:p>
+            <a:pPr algn="l"/>
+            <a:r>
+              <a:rPr sz="1300">
+                <a:solidFill>
+                  <a:srgbClr val="26323F"/>
+                </a:solidFill>
+                <a:latin typeface="Times New Roman"/>
+              </a:rPr>
+              <a:t>M. Pontiki et al., “SemEval-2016 Task 5: Aspect based sentiment analysis,” in Proc. SemEval, 2016, pp. 19–30.</a:t>
+            </a:r>
+          </a:p>
+        </p:txBody>
+      </p:sp>
+      <p:sp>
+        <p:nvSpPr>
+          <p:cNvPr id="25" name="Reference card 7"/>
+          <p:cNvSpPr/>
+          <p:nvPr/>
+        </p:nvSpPr>
+        <p:spPr>
+          <a:xfrm>
+            <a:off x="365760" y="4946904"/>
+            <a:ext cx="8229600" cy="594360"/>
+          </a:xfrm>
+          <a:prstGeom prst="roundRect">
+            <a:avLst>
+              <a:gd name="adj" fmla="val 8000"/>
+            </a:avLst>
+          </a:prstGeom>
+          <a:solidFill>
+            <a:srgbClr val="FFFFFF"/>
+          </a:solidFill>
+          <a:ln w="12700">
+            <a:solidFill>
+              <a:srgbClr val="9DB7C9"/>
+            </a:solidFill>
+          </a:ln>
+          <a:effectLst/>
+        </p:spPr>
+        <p:style>
+          <a:lnRef idx="1">
+            <a:schemeClr val="accent1"/>
+          </a:lnRef>
+          <a:fillRef idx="3">
+            <a:schemeClr val="accent1"/>
+          </a:fillRef>
+          <a:effectRef idx="2">
+            <a:schemeClr val="accent1"/>
+          </a:effectRef>
+          <a:fontRef idx="minor">
+            <a:schemeClr val="lt1"/>
+          </a:fontRef>
+        </p:style>
+        <p:txBody>
+          <a:bodyPr rtlCol="0" anchor="ctr"/>
+          <a:lstStyle/>
+          <a:p>
+            <a:pPr algn="ctr"/>
+          </a:p>
+        </p:txBody>
+      </p:sp>
+      <p:sp>
+        <p:nvSpPr>
+          <p:cNvPr id="26" name="Reference id 7"/>
+          <p:cNvSpPr txBox="1"/>
+          <p:nvPr/>
+        </p:nvSpPr>
+        <p:spPr>
+          <a:xfrm>
+            <a:off x="502920" y="4974336"/>
+            <a:ext cx="685800" cy="539496"/>
+          </a:xfrm>
+          <a:prstGeom prst="rect">
+            <a:avLst/>
+          </a:prstGeom>
+          <a:noFill/>
+        </p:spPr>
+        <p:txBody>
+          <a:bodyPr wrap="square" anchor="ctr" lIns="0" rIns="0" tIns="0" bIns="0">
+            <a:spAutoFit/>
+          </a:bodyPr>
+          <a:lstStyle/>
+          <a:p>
+            <a:pPr algn="l"/>
+            <a:r>
+              <a:rPr sz="1400" b="1">
+                <a:solidFill>
+                  <a:srgbClr val="1F6F78"/>
+                </a:solidFill>
+                <a:latin typeface="Times New Roman"/>
+              </a:rPr>
+              <a:t>[7]</a:t>
+            </a:r>
+          </a:p>
+        </p:txBody>
+      </p:sp>
+      <p:sp>
+        <p:nvSpPr>
+          <p:cNvPr id="27" name="Reference text 7"/>
+          <p:cNvSpPr txBox="1"/>
+          <p:nvPr/>
+        </p:nvSpPr>
+        <p:spPr>
+          <a:xfrm>
+            <a:off x="1234440" y="4974336"/>
+            <a:ext cx="7269480" cy="539496"/>
+          </a:xfrm>
+          <a:prstGeom prst="rect">
+            <a:avLst/>
+          </a:prstGeom>
+          <a:noFill/>
+        </p:spPr>
+        <p:txBody>
+          <a:bodyPr wrap="square" anchor="ctr" lIns="0" rIns="0" tIns="0" bIns="0">
+            <a:spAutoFit/>
+          </a:bodyPr>
+          <a:lstStyle/>
+          <a:p>
+            <a:pPr algn="l"/>
+            <a:r>
+              <a:rPr sz="1300">
+                <a:solidFill>
+                  <a:srgbClr val="26323F"/>
+                </a:solidFill>
+                <a:latin typeface="Times New Roman"/>
+              </a:rPr>
+              <a:t>A. Vaswani et al., “Attention is all you need,” in Proc. NeurIPS, 2017, pp. 5998–6008.</a:t>
+            </a:r>
+          </a:p>
+        </p:txBody>
+      </p:sp>
+      <p:sp>
+        <p:nvSpPr>
+          <p:cNvPr id="28" name="Reference card 8"/>
+          <p:cNvSpPr/>
+          <p:nvPr/>
+        </p:nvSpPr>
+        <p:spPr>
+          <a:xfrm>
+            <a:off x="365760" y="5596128"/>
+            <a:ext cx="8229600" cy="457200"/>
+          </a:xfrm>
+          <a:prstGeom prst="roundRect">
+            <a:avLst>
+              <a:gd name="adj" fmla="val 8000"/>
+            </a:avLst>
+          </a:prstGeom>
+          <a:solidFill>
+            <a:srgbClr val="FFFFFF"/>
+          </a:solidFill>
+          <a:ln w="12700">
+            <a:solidFill>
+              <a:srgbClr val="9DB7C9"/>
+            </a:solidFill>
+          </a:ln>
+          <a:effectLst/>
+        </p:spPr>
+        <p:style>
+          <a:lnRef idx="1">
+            <a:schemeClr val="accent1"/>
+          </a:lnRef>
+          <a:fillRef idx="3">
+            <a:schemeClr val="accent1"/>
+          </a:fillRef>
+          <a:effectRef idx="2">
+            <a:schemeClr val="accent1"/>
+          </a:effectRef>
+          <a:fontRef idx="minor">
+            <a:schemeClr val="lt1"/>
+          </a:fontRef>
+        </p:style>
+        <p:txBody>
+          <a:bodyPr rtlCol="0" anchor="ctr"/>
+          <a:lstStyle/>
+          <a:p>
+            <a:pPr algn="ctr"/>
+          </a:p>
+        </p:txBody>
+      </p:sp>
+      <p:sp>
+        <p:nvSpPr>
+          <p:cNvPr id="29" name="Reference id 8"/>
+          <p:cNvSpPr txBox="1"/>
+          <p:nvPr/>
+        </p:nvSpPr>
+        <p:spPr>
+          <a:xfrm>
+            <a:off x="502920" y="5623560"/>
+            <a:ext cx="685800" cy="402336"/>
+          </a:xfrm>
+          <a:prstGeom prst="rect">
+            <a:avLst/>
+          </a:prstGeom>
+          <a:noFill/>
+        </p:spPr>
+        <p:txBody>
+          <a:bodyPr wrap="square" anchor="ctr" lIns="0" rIns="0" tIns="0" bIns="0">
+            <a:spAutoFit/>
+          </a:bodyPr>
+          <a:lstStyle/>
+          <a:p>
+            <a:pPr algn="l"/>
+            <a:r>
+              <a:rPr sz="1400" b="1">
+                <a:solidFill>
+                  <a:srgbClr val="1F6F78"/>
+                </a:solidFill>
+                <a:latin typeface="Times New Roman"/>
+              </a:rPr>
+              <a:t>[8]</a:t>
+            </a:r>
+          </a:p>
+        </p:txBody>
+      </p:sp>
+      <p:sp>
+        <p:nvSpPr>
+          <p:cNvPr id="30" name="Reference text 8"/>
+          <p:cNvSpPr txBox="1"/>
+          <p:nvPr/>
+        </p:nvSpPr>
+        <p:spPr>
+          <a:xfrm>
+            <a:off x="1234440" y="5623560"/>
+            <a:ext cx="7269480" cy="402336"/>
+          </a:xfrm>
+          <a:prstGeom prst="rect">
+            <a:avLst/>
+          </a:prstGeom>
+          <a:noFill/>
+        </p:spPr>
+        <p:txBody>
+          <a:bodyPr wrap="square" anchor="ctr" lIns="0" rIns="0" tIns="0" bIns="0">
+            <a:spAutoFit/>
+          </a:bodyPr>
+          <a:lstStyle/>
+          <a:p>
+            <a:pPr algn="l"/>
+            <a:r>
+              <a:rPr sz="1300">
+                <a:solidFill>
+                  <a:srgbClr val="26323F"/>
+                </a:solidFill>
+                <a:latin typeface="Times New Roman"/>
+              </a:rPr>
+              <a:t>J. Devlin et al., “BERT: Pre-training of deep bidirectional transformers,” in Proc. NAACL-HLT, 2019, pp. 4171–4186.</a:t>
+            </a:r>
+          </a:p>
+        </p:txBody>
+      </p:sp>
+      <p:sp>
+        <p:nvSpPr>
+          <p:cNvPr id="31" name="Reference note"/>
+          <p:cNvSpPr txBox="1"/>
+          <p:nvPr/>
+        </p:nvSpPr>
+        <p:spPr>
+          <a:xfrm>
+            <a:off x="365760" y="6126480"/>
+            <a:ext cx="8229600" cy="365760"/>
+          </a:xfrm>
+          <a:prstGeom prst="rect">
+            <a:avLst/>
+          </a:prstGeom>
+          <a:noFill/>
+        </p:spPr>
+        <p:txBody>
+          <a:bodyPr wrap="square" anchor="t" lIns="0" rIns="0" tIns="0" bIns="0">
+            <a:spAutoFit/>
+          </a:bodyPr>
+          <a:lstStyle/>
+          <a:p>
+            <a:pPr algn="ctr"/>
+            <a:r>
+              <a:rPr sz="1300" i="1">
+                <a:solidFill>
+                  <a:srgbClr val="556575"/>
+                </a:solidFill>
+                <a:latin typeface="Times New Roman"/>
+              </a:rPr>
+              <a:t>These eight references are the only sources cited in this presentation.</a:t>
+            </a:r>
+          </a:p>
+        </p:txBody>
+      </p:sp>
     </p:spTree>
   </p:cSld>
   <p:clrMapOvr>

</xml_diff>